<commit_message>
Adiciona apresentação do Nexus Gestão
</commit_message>
<xml_diff>
--- a/Apresentação Nexus.pptx
+++ b/Apresentação Nexus.pptx
@@ -1,23 +1,23 @@
 
 <file path=ppt/presentation.xml><?xml version="1.0" encoding="utf-8"?>
-<p:presentation xmlns:a="http://schemas.openxmlformats.org/drawingml/2006/main" xmlns:r="http://schemas.openxmlformats.org/officeDocument/2006/relationships" xmlns:p="http://schemas.openxmlformats.org/presentationml/2006/main" saveSubsetFonts="1" autoCompressPictures="0">
+<p:presentation xmlns:a="http://schemas.openxmlformats.org/drawingml/2006/main" xmlns:r="http://schemas.openxmlformats.org/officeDocument/2006/relationships" xmlns:p="http://schemas.openxmlformats.org/presentationml/2006/main" autoCompressPictures="0">
   <p:sldMasterIdLst>
     <p:sldMasterId id="2147483648" r:id="rId1"/>
   </p:sldMasterIdLst>
   <p:sldIdLst>
-    <p:sldId id="256" r:id="rId7"/>
-    <p:sldId id="257" r:id="rId8"/>
-    <p:sldId id="258" r:id="rId9"/>
-    <p:sldId id="259" r:id="rId10"/>
-    <p:sldId id="260" r:id="rId11"/>
-    <p:sldId id="261" r:id="rId12"/>
-    <p:sldId id="262" r:id="rId13"/>
-    <p:sldId id="263" r:id="rId14"/>
-    <p:sldId id="264" r:id="rId15"/>
-    <p:sldId id="265" r:id="rId16"/>
-    <p:sldId id="266" r:id="rId17"/>
+    <p:sldId id="256" r:id="rId3"/>
+    <p:sldId id="257" r:id="rId4"/>
+    <p:sldId id="258" r:id="rId5"/>
+    <p:sldId id="259" r:id="rId6"/>
+    <p:sldId id="260" r:id="rId7"/>
+    <p:sldId id="261" r:id="rId8"/>
+    <p:sldId id="262" r:id="rId9"/>
+    <p:sldId id="263" r:id="rId10"/>
+    <p:sldId id="264" r:id="rId11"/>
+    <p:sldId id="265" r:id="rId12"/>
+    <p:sldId id="266" r:id="rId13"/>
   </p:sldIdLst>
-  <p:sldSz cx="12191695" cy="6858000" type="screen4x3"/>
+  <p:sldSz cx="12191365" cy="6858000" type="screen4x3"/>
   <p:notesSz cx="6858000" cy="9144000"/>
   <p:defaultTextStyle>
     <a:defPPr>
@@ -114,6 +114,22 @@
       </a:defRPr>
     </a:lvl9pPr>
   </p:defaultTextStyle>
+  <p:extLst>
+    <p:ext uri="{EFAFB233-063F-42B5-8137-9DF3F51BA10A}">
+      <p15:sldGuideLst xmlns:p15="http://schemas.microsoft.com/office/powerpoint/2012/main">
+        <p15:guide id="1" orient="horz" pos="2160" userDrawn="1">
+          <p15:clr>
+            <a:srgbClr val="A4A3A4"/>
+          </p15:clr>
+        </p15:guide>
+        <p15:guide id="2" pos="2880" userDrawn="1">
+          <p15:clr>
+            <a:srgbClr val="A4A3A4"/>
+          </p15:clr>
+        </p15:guide>
+      </p15:sldGuideLst>
+    </p:ext>
+  </p:extLst>
 </p:presentation>
 </file>
 
@@ -298,7 +314,6 @@
           <a:p>
             <a:fld id="{5BCAD085-E8A6-8845-BD4E-CB4CCA059FC4}" type="datetimeFigureOut">
               <a:rPr lang="en-US" smtClean="0"/>
-              <a:t>1/27/13</a:t>
             </a:fld>
             <a:endParaRPr lang="en-US"/>
           </a:p>
@@ -340,18 +355,12 @@
           <a:p>
             <a:fld id="{C1FF6DA9-008F-8B48-92A6-B652298478BF}" type="slidenum">
               <a:rPr lang="en-US" smtClean="0"/>
-              <a:t>‹#›</a:t>
             </a:fld>
             <a:endParaRPr lang="en-US"/>
           </a:p>
         </p:txBody>
       </p:sp>
     </p:spTree>
-    <p:extLst>
-      <p:ext uri="{BB962C8B-B14F-4D97-AF65-F5344CB8AC3E}">
-        <p14:creationId xmlns:p14="http://schemas.microsoft.com/office/powerpoint/2010/main" val="3168075583"/>
-      </p:ext>
-    </p:extLst>
   </p:cSld>
   <p:clrMapOvr>
     <a:masterClrMapping/>
@@ -419,6 +428,7 @@
               <a:rPr lang="en-US" smtClean="0"/>
               <a:t>Click to edit Master text styles</a:t>
             </a:r>
+            <a:endParaRPr lang="en-US" smtClean="0"/>
           </a:p>
           <a:p>
             <a:pPr lvl="1"/>
@@ -426,6 +436,7 @@
               <a:rPr lang="en-US" smtClean="0"/>
               <a:t>Second level</a:t>
             </a:r>
+            <a:endParaRPr lang="en-US" smtClean="0"/>
           </a:p>
           <a:p>
             <a:pPr lvl="2"/>
@@ -433,6 +444,7 @@
               <a:rPr lang="en-US" smtClean="0"/>
               <a:t>Third level</a:t>
             </a:r>
+            <a:endParaRPr lang="en-US" smtClean="0"/>
           </a:p>
           <a:p>
             <a:pPr lvl="3"/>
@@ -440,6 +452,7 @@
               <a:rPr lang="en-US" smtClean="0"/>
               <a:t>Fourth level</a:t>
             </a:r>
+            <a:endParaRPr lang="en-US" smtClean="0"/>
           </a:p>
           <a:p>
             <a:pPr lvl="4"/>
@@ -468,7 +481,6 @@
           <a:p>
             <a:fld id="{5BCAD085-E8A6-8845-BD4E-CB4CCA059FC4}" type="datetimeFigureOut">
               <a:rPr lang="en-US" smtClean="0"/>
-              <a:t>1/27/13</a:t>
             </a:fld>
             <a:endParaRPr lang="en-US"/>
           </a:p>
@@ -510,18 +522,12 @@
           <a:p>
             <a:fld id="{C1FF6DA9-008F-8B48-92A6-B652298478BF}" type="slidenum">
               <a:rPr lang="en-US" smtClean="0"/>
-              <a:t>‹#›</a:t>
             </a:fld>
             <a:endParaRPr lang="en-US"/>
           </a:p>
         </p:txBody>
       </p:sp>
     </p:spTree>
-    <p:extLst>
-      <p:ext uri="{BB962C8B-B14F-4D97-AF65-F5344CB8AC3E}">
-        <p14:creationId xmlns:p14="http://schemas.microsoft.com/office/powerpoint/2010/main" val="2910927964"/>
-      </p:ext>
-    </p:extLst>
   </p:cSld>
   <p:clrMapOvr>
     <a:masterClrMapping/>
@@ -599,6 +605,7 @@
               <a:rPr lang="en-US" smtClean="0"/>
               <a:t>Click to edit Master text styles</a:t>
             </a:r>
+            <a:endParaRPr lang="en-US" smtClean="0"/>
           </a:p>
           <a:p>
             <a:pPr lvl="1"/>
@@ -606,6 +613,7 @@
               <a:rPr lang="en-US" smtClean="0"/>
               <a:t>Second level</a:t>
             </a:r>
+            <a:endParaRPr lang="en-US" smtClean="0"/>
           </a:p>
           <a:p>
             <a:pPr lvl="2"/>
@@ -613,6 +621,7 @@
               <a:rPr lang="en-US" smtClean="0"/>
               <a:t>Third level</a:t>
             </a:r>
+            <a:endParaRPr lang="en-US" smtClean="0"/>
           </a:p>
           <a:p>
             <a:pPr lvl="3"/>
@@ -620,6 +629,7 @@
               <a:rPr lang="en-US" smtClean="0"/>
               <a:t>Fourth level</a:t>
             </a:r>
+            <a:endParaRPr lang="en-US" smtClean="0"/>
           </a:p>
           <a:p>
             <a:pPr lvl="4"/>
@@ -648,7 +658,6 @@
           <a:p>
             <a:fld id="{5BCAD085-E8A6-8845-BD4E-CB4CCA059FC4}" type="datetimeFigureOut">
               <a:rPr lang="en-US" smtClean="0"/>
-              <a:t>1/27/13</a:t>
             </a:fld>
             <a:endParaRPr lang="en-US"/>
           </a:p>
@@ -690,18 +699,12 @@
           <a:p>
             <a:fld id="{C1FF6DA9-008F-8B48-92A6-B652298478BF}" type="slidenum">
               <a:rPr lang="en-US" smtClean="0"/>
-              <a:t>‹#›</a:t>
             </a:fld>
             <a:endParaRPr lang="en-US"/>
           </a:p>
         </p:txBody>
       </p:sp>
     </p:spTree>
-    <p:extLst>
-      <p:ext uri="{BB962C8B-B14F-4D97-AF65-F5344CB8AC3E}">
-        <p14:creationId xmlns:p14="http://schemas.microsoft.com/office/powerpoint/2010/main" val="3612223792"/>
-      </p:ext>
-    </p:extLst>
   </p:cSld>
   <p:clrMapOvr>
     <a:masterClrMapping/>
@@ -769,6 +772,7 @@
               <a:rPr lang="en-US" smtClean="0"/>
               <a:t>Click to edit Master text styles</a:t>
             </a:r>
+            <a:endParaRPr lang="en-US" smtClean="0"/>
           </a:p>
           <a:p>
             <a:pPr lvl="1"/>
@@ -776,6 +780,7 @@
               <a:rPr lang="en-US" smtClean="0"/>
               <a:t>Second level</a:t>
             </a:r>
+            <a:endParaRPr lang="en-US" smtClean="0"/>
           </a:p>
           <a:p>
             <a:pPr lvl="2"/>
@@ -783,6 +788,7 @@
               <a:rPr lang="en-US" smtClean="0"/>
               <a:t>Third level</a:t>
             </a:r>
+            <a:endParaRPr lang="en-US" smtClean="0"/>
           </a:p>
           <a:p>
             <a:pPr lvl="3"/>
@@ -790,6 +796,7 @@
               <a:rPr lang="en-US" smtClean="0"/>
               <a:t>Fourth level</a:t>
             </a:r>
+            <a:endParaRPr lang="en-US" smtClean="0"/>
           </a:p>
           <a:p>
             <a:pPr lvl="4"/>
@@ -818,7 +825,6 @@
           <a:p>
             <a:fld id="{5BCAD085-E8A6-8845-BD4E-CB4CCA059FC4}" type="datetimeFigureOut">
               <a:rPr lang="en-US" smtClean="0"/>
-              <a:t>1/27/13</a:t>
             </a:fld>
             <a:endParaRPr lang="en-US"/>
           </a:p>
@@ -860,18 +866,12 @@
           <a:p>
             <a:fld id="{C1FF6DA9-008F-8B48-92A6-B652298478BF}" type="slidenum">
               <a:rPr lang="en-US" smtClean="0"/>
-              <a:t>‹#›</a:t>
             </a:fld>
             <a:endParaRPr lang="en-US"/>
           </a:p>
         </p:txBody>
       </p:sp>
     </p:spTree>
-    <p:extLst>
-      <p:ext uri="{BB962C8B-B14F-4D97-AF65-F5344CB8AC3E}">
-        <p14:creationId xmlns:p14="http://schemas.microsoft.com/office/powerpoint/2010/main" val="2614314258"/>
-      </p:ext>
-    </p:extLst>
   </p:cSld>
   <p:clrMapOvr>
     <a:masterClrMapping/>
@@ -1044,6 +1044,7 @@
               <a:rPr lang="en-US" smtClean="0"/>
               <a:t>Click to edit Master text styles</a:t>
             </a:r>
+            <a:endParaRPr lang="en-US" smtClean="0"/>
           </a:p>
         </p:txBody>
       </p:sp>
@@ -1064,7 +1065,6 @@
           <a:p>
             <a:fld id="{5BCAD085-E8A6-8845-BD4E-CB4CCA059FC4}" type="datetimeFigureOut">
               <a:rPr lang="en-US" smtClean="0"/>
-              <a:t>1/27/13</a:t>
             </a:fld>
             <a:endParaRPr lang="en-US"/>
           </a:p>
@@ -1106,18 +1106,12 @@
           <a:p>
             <a:fld id="{C1FF6DA9-008F-8B48-92A6-B652298478BF}" type="slidenum">
               <a:rPr lang="en-US" smtClean="0"/>
-              <a:t>‹#›</a:t>
             </a:fld>
             <a:endParaRPr lang="en-US"/>
           </a:p>
         </p:txBody>
       </p:sp>
     </p:spTree>
-    <p:extLst>
-      <p:ext uri="{BB962C8B-B14F-4D97-AF65-F5344CB8AC3E}">
-        <p14:creationId xmlns:p14="http://schemas.microsoft.com/office/powerpoint/2010/main" val="960648375"/>
-      </p:ext>
-    </p:extLst>
   </p:cSld>
   <p:clrMapOvr>
     <a:masterClrMapping/>
@@ -1218,6 +1212,7 @@
               <a:rPr lang="en-US" smtClean="0"/>
               <a:t>Click to edit Master text styles</a:t>
             </a:r>
+            <a:endParaRPr lang="en-US" smtClean="0"/>
           </a:p>
           <a:p>
             <a:pPr lvl="1"/>
@@ -1225,6 +1220,7 @@
               <a:rPr lang="en-US" smtClean="0"/>
               <a:t>Second level</a:t>
             </a:r>
+            <a:endParaRPr lang="en-US" smtClean="0"/>
           </a:p>
           <a:p>
             <a:pPr lvl="2"/>
@@ -1232,6 +1228,7 @@
               <a:rPr lang="en-US" smtClean="0"/>
               <a:t>Third level</a:t>
             </a:r>
+            <a:endParaRPr lang="en-US" smtClean="0"/>
           </a:p>
           <a:p>
             <a:pPr lvl="3"/>
@@ -1239,6 +1236,7 @@
               <a:rPr lang="en-US" smtClean="0"/>
               <a:t>Fourth level</a:t>
             </a:r>
+            <a:endParaRPr lang="en-US" smtClean="0"/>
           </a:p>
           <a:p>
             <a:pPr lvl="4"/>
@@ -1303,6 +1301,7 @@
               <a:rPr lang="en-US" smtClean="0"/>
               <a:t>Click to edit Master text styles</a:t>
             </a:r>
+            <a:endParaRPr lang="en-US" smtClean="0"/>
           </a:p>
           <a:p>
             <a:pPr lvl="1"/>
@@ -1310,6 +1309,7 @@
               <a:rPr lang="en-US" smtClean="0"/>
               <a:t>Second level</a:t>
             </a:r>
+            <a:endParaRPr lang="en-US" smtClean="0"/>
           </a:p>
           <a:p>
             <a:pPr lvl="2"/>
@@ -1317,6 +1317,7 @@
               <a:rPr lang="en-US" smtClean="0"/>
               <a:t>Third level</a:t>
             </a:r>
+            <a:endParaRPr lang="en-US" smtClean="0"/>
           </a:p>
           <a:p>
             <a:pPr lvl="3"/>
@@ -1324,6 +1325,7 @@
               <a:rPr lang="en-US" smtClean="0"/>
               <a:t>Fourth level</a:t>
             </a:r>
+            <a:endParaRPr lang="en-US" smtClean="0"/>
           </a:p>
           <a:p>
             <a:pPr lvl="4"/>
@@ -1352,7 +1354,6 @@
           <a:p>
             <a:fld id="{5BCAD085-E8A6-8845-BD4E-CB4CCA059FC4}" type="datetimeFigureOut">
               <a:rPr lang="en-US" smtClean="0"/>
-              <a:t>1/27/13</a:t>
             </a:fld>
             <a:endParaRPr lang="en-US"/>
           </a:p>
@@ -1394,18 +1395,12 @@
           <a:p>
             <a:fld id="{C1FF6DA9-008F-8B48-92A6-B652298478BF}" type="slidenum">
               <a:rPr lang="en-US" smtClean="0"/>
-              <a:t>‹#›</a:t>
             </a:fld>
             <a:endParaRPr lang="en-US"/>
           </a:p>
         </p:txBody>
       </p:sp>
     </p:spTree>
-    <p:extLst>
-      <p:ext uri="{BB962C8B-B14F-4D97-AF65-F5344CB8AC3E}">
-        <p14:creationId xmlns:p14="http://schemas.microsoft.com/office/powerpoint/2010/main" val="2782244947"/>
-      </p:ext>
-    </p:extLst>
   </p:cSld>
   <p:clrMapOvr>
     <a:masterClrMapping/>
@@ -1519,6 +1514,7 @@
               <a:rPr lang="en-US" smtClean="0"/>
               <a:t>Click to edit Master text styles</a:t>
             </a:r>
+            <a:endParaRPr lang="en-US" smtClean="0"/>
           </a:p>
         </p:txBody>
       </p:sp>
@@ -1575,6 +1571,7 @@
               <a:rPr lang="en-US" smtClean="0"/>
               <a:t>Click to edit Master text styles</a:t>
             </a:r>
+            <a:endParaRPr lang="en-US" smtClean="0"/>
           </a:p>
           <a:p>
             <a:pPr lvl="1"/>
@@ -1582,6 +1579,7 @@
               <a:rPr lang="en-US" smtClean="0"/>
               <a:t>Second level</a:t>
             </a:r>
+            <a:endParaRPr lang="en-US" smtClean="0"/>
           </a:p>
           <a:p>
             <a:pPr lvl="2"/>
@@ -1589,6 +1587,7 @@
               <a:rPr lang="en-US" smtClean="0"/>
               <a:t>Third level</a:t>
             </a:r>
+            <a:endParaRPr lang="en-US" smtClean="0"/>
           </a:p>
           <a:p>
             <a:pPr lvl="3"/>
@@ -1596,6 +1595,7 @@
               <a:rPr lang="en-US" smtClean="0"/>
               <a:t>Fourth level</a:t>
             </a:r>
+            <a:endParaRPr lang="en-US" smtClean="0"/>
           </a:p>
           <a:p>
             <a:pPr lvl="4"/>
@@ -1669,6 +1669,7 @@
               <a:rPr lang="en-US" smtClean="0"/>
               <a:t>Click to edit Master text styles</a:t>
             </a:r>
+            <a:endParaRPr lang="en-US" smtClean="0"/>
           </a:p>
         </p:txBody>
       </p:sp>
@@ -1725,6 +1726,7 @@
               <a:rPr lang="en-US" smtClean="0"/>
               <a:t>Click to edit Master text styles</a:t>
             </a:r>
+            <a:endParaRPr lang="en-US" smtClean="0"/>
           </a:p>
           <a:p>
             <a:pPr lvl="1"/>
@@ -1732,6 +1734,7 @@
               <a:rPr lang="en-US" smtClean="0"/>
               <a:t>Second level</a:t>
             </a:r>
+            <a:endParaRPr lang="en-US" smtClean="0"/>
           </a:p>
           <a:p>
             <a:pPr lvl="2"/>
@@ -1739,6 +1742,7 @@
               <a:rPr lang="en-US" smtClean="0"/>
               <a:t>Third level</a:t>
             </a:r>
+            <a:endParaRPr lang="en-US" smtClean="0"/>
           </a:p>
           <a:p>
             <a:pPr lvl="3"/>
@@ -1746,6 +1750,7 @@
               <a:rPr lang="en-US" smtClean="0"/>
               <a:t>Fourth level</a:t>
             </a:r>
+            <a:endParaRPr lang="en-US" smtClean="0"/>
           </a:p>
           <a:p>
             <a:pPr lvl="4"/>
@@ -1774,7 +1779,6 @@
           <a:p>
             <a:fld id="{5BCAD085-E8A6-8845-BD4E-CB4CCA059FC4}" type="datetimeFigureOut">
               <a:rPr lang="en-US" smtClean="0"/>
-              <a:t>1/27/13</a:t>
             </a:fld>
             <a:endParaRPr lang="en-US"/>
           </a:p>
@@ -1816,18 +1820,12 @@
           <a:p>
             <a:fld id="{C1FF6DA9-008F-8B48-92A6-B652298478BF}" type="slidenum">
               <a:rPr lang="en-US" smtClean="0"/>
-              <a:t>‹#›</a:t>
             </a:fld>
             <a:endParaRPr lang="en-US"/>
           </a:p>
         </p:txBody>
       </p:sp>
     </p:spTree>
-    <p:extLst>
-      <p:ext uri="{BB962C8B-B14F-4D97-AF65-F5344CB8AC3E}">
-        <p14:creationId xmlns:p14="http://schemas.microsoft.com/office/powerpoint/2010/main" val="990158736"/>
-      </p:ext>
-    </p:extLst>
   </p:cSld>
   <p:clrMapOvr>
     <a:masterClrMapping/>
@@ -1892,7 +1890,6 @@
           <a:p>
             <a:fld id="{5BCAD085-E8A6-8845-BD4E-CB4CCA059FC4}" type="datetimeFigureOut">
               <a:rPr lang="en-US" smtClean="0"/>
-              <a:t>1/27/13</a:t>
             </a:fld>
             <a:endParaRPr lang="en-US"/>
           </a:p>
@@ -1934,18 +1931,12 @@
           <a:p>
             <a:fld id="{C1FF6DA9-008F-8B48-92A6-B652298478BF}" type="slidenum">
               <a:rPr lang="en-US" smtClean="0"/>
-              <a:t>‹#›</a:t>
             </a:fld>
             <a:endParaRPr lang="en-US"/>
           </a:p>
         </p:txBody>
       </p:sp>
     </p:spTree>
-    <p:extLst>
-      <p:ext uri="{BB962C8B-B14F-4D97-AF65-F5344CB8AC3E}">
-        <p14:creationId xmlns:p14="http://schemas.microsoft.com/office/powerpoint/2010/main" val="727027711"/>
-      </p:ext>
-    </p:extLst>
   </p:cSld>
   <p:clrMapOvr>
     <a:masterClrMapping/>
@@ -1987,7 +1978,6 @@
           <a:p>
             <a:fld id="{5BCAD085-E8A6-8845-BD4E-CB4CCA059FC4}" type="datetimeFigureOut">
               <a:rPr lang="en-US" smtClean="0"/>
-              <a:t>1/27/13</a:t>
             </a:fld>
             <a:endParaRPr lang="en-US"/>
           </a:p>
@@ -2029,18 +2019,12 @@
           <a:p>
             <a:fld id="{C1FF6DA9-008F-8B48-92A6-B652298478BF}" type="slidenum">
               <a:rPr lang="en-US" smtClean="0"/>
-              <a:t>‹#›</a:t>
             </a:fld>
             <a:endParaRPr lang="en-US"/>
           </a:p>
         </p:txBody>
       </p:sp>
     </p:spTree>
-    <p:extLst>
-      <p:ext uri="{BB962C8B-B14F-4D97-AF65-F5344CB8AC3E}">
-        <p14:creationId xmlns:p14="http://schemas.microsoft.com/office/powerpoint/2010/main" val="1212999818"/>
-      </p:ext>
-    </p:extLst>
   </p:cSld>
   <p:clrMapOvr>
     <a:masterClrMapping/>
@@ -2150,6 +2134,7 @@
               <a:rPr lang="en-US" smtClean="0"/>
               <a:t>Click to edit Master text styles</a:t>
             </a:r>
+            <a:endParaRPr lang="en-US" smtClean="0"/>
           </a:p>
           <a:p>
             <a:pPr lvl="1"/>
@@ -2157,6 +2142,7 @@
               <a:rPr lang="en-US" smtClean="0"/>
               <a:t>Second level</a:t>
             </a:r>
+            <a:endParaRPr lang="en-US" smtClean="0"/>
           </a:p>
           <a:p>
             <a:pPr lvl="2"/>
@@ -2164,6 +2150,7 @@
               <a:rPr lang="en-US" smtClean="0"/>
               <a:t>Third level</a:t>
             </a:r>
+            <a:endParaRPr lang="en-US" smtClean="0"/>
           </a:p>
           <a:p>
             <a:pPr lvl="3"/>
@@ -2171,6 +2158,7 @@
               <a:rPr lang="en-US" smtClean="0"/>
               <a:t>Fourth level</a:t>
             </a:r>
+            <a:endParaRPr lang="en-US" smtClean="0"/>
           </a:p>
           <a:p>
             <a:pPr lvl="4"/>
@@ -2244,6 +2232,7 @@
               <a:rPr lang="en-US" smtClean="0"/>
               <a:t>Click to edit Master text styles</a:t>
             </a:r>
+            <a:endParaRPr lang="en-US" smtClean="0"/>
           </a:p>
         </p:txBody>
       </p:sp>
@@ -2264,7 +2253,6 @@
           <a:p>
             <a:fld id="{5BCAD085-E8A6-8845-BD4E-CB4CCA059FC4}" type="datetimeFigureOut">
               <a:rPr lang="en-US" smtClean="0"/>
-              <a:t>1/27/13</a:t>
             </a:fld>
             <a:endParaRPr lang="en-US"/>
           </a:p>
@@ -2306,18 +2294,12 @@
           <a:p>
             <a:fld id="{C1FF6DA9-008F-8B48-92A6-B652298478BF}" type="slidenum">
               <a:rPr lang="en-US" smtClean="0"/>
-              <a:t>‹#›</a:t>
             </a:fld>
             <a:endParaRPr lang="en-US"/>
           </a:p>
         </p:txBody>
       </p:sp>
     </p:spTree>
-    <p:extLst>
-      <p:ext uri="{BB962C8B-B14F-4D97-AF65-F5344CB8AC3E}">
-        <p14:creationId xmlns:p14="http://schemas.microsoft.com/office/powerpoint/2010/main" val="1840726560"/>
-      </p:ext>
-    </p:extLst>
   </p:cSld>
   <p:clrMapOvr>
     <a:masterClrMapping/>
@@ -2497,6 +2479,7 @@
               <a:rPr lang="en-US" smtClean="0"/>
               <a:t>Click to edit Master text styles</a:t>
             </a:r>
+            <a:endParaRPr lang="en-US" smtClean="0"/>
           </a:p>
         </p:txBody>
       </p:sp>
@@ -2517,7 +2500,6 @@
           <a:p>
             <a:fld id="{5BCAD085-E8A6-8845-BD4E-CB4CCA059FC4}" type="datetimeFigureOut">
               <a:rPr lang="en-US" smtClean="0"/>
-              <a:t>1/27/13</a:t>
             </a:fld>
             <a:endParaRPr lang="en-US"/>
           </a:p>
@@ -2559,18 +2541,12 @@
           <a:p>
             <a:fld id="{C1FF6DA9-008F-8B48-92A6-B652298478BF}" type="slidenum">
               <a:rPr lang="en-US" smtClean="0"/>
-              <a:t>‹#›</a:t>
             </a:fld>
             <a:endParaRPr lang="en-US"/>
           </a:p>
         </p:txBody>
       </p:sp>
     </p:spTree>
-    <p:extLst>
-      <p:ext uri="{BB962C8B-B14F-4D97-AF65-F5344CB8AC3E}">
-        <p14:creationId xmlns:p14="http://schemas.microsoft.com/office/powerpoint/2010/main" val="3889236939"/>
-      </p:ext>
-    </p:extLst>
   </p:cSld>
   <p:clrMapOvr>
     <a:masterClrMapping/>
@@ -2663,6 +2639,7 @@
               <a:rPr lang="en-US" smtClean="0"/>
               <a:t>Click to edit Master text styles</a:t>
             </a:r>
+            <a:endParaRPr lang="en-US" smtClean="0"/>
           </a:p>
           <a:p>
             <a:pPr lvl="1"/>
@@ -2670,6 +2647,7 @@
               <a:rPr lang="en-US" smtClean="0"/>
               <a:t>Second level</a:t>
             </a:r>
+            <a:endParaRPr lang="en-US" smtClean="0"/>
           </a:p>
           <a:p>
             <a:pPr lvl="2"/>
@@ -2677,6 +2655,7 @@
               <a:rPr lang="en-US" smtClean="0"/>
               <a:t>Third level</a:t>
             </a:r>
+            <a:endParaRPr lang="en-US" smtClean="0"/>
           </a:p>
           <a:p>
             <a:pPr lvl="3"/>
@@ -2684,6 +2663,7 @@
               <a:rPr lang="en-US" smtClean="0"/>
               <a:t>Fourth level</a:t>
             </a:r>
+            <a:endParaRPr lang="en-US" smtClean="0"/>
           </a:p>
           <a:p>
             <a:pPr lvl="4"/>
@@ -2730,7 +2710,6 @@
           <a:p>
             <a:fld id="{5BCAD085-E8A6-8845-BD4E-CB4CCA059FC4}" type="datetimeFigureOut">
               <a:rPr lang="en-US" smtClean="0"/>
-              <a:t>1/27/13</a:t>
             </a:fld>
             <a:endParaRPr lang="en-US"/>
           </a:p>
@@ -2808,18 +2787,12 @@
           <a:p>
             <a:fld id="{C1FF6DA9-008F-8B48-92A6-B652298478BF}" type="slidenum">
               <a:rPr lang="en-US" smtClean="0"/>
-              <a:t>‹#›</a:t>
             </a:fld>
             <a:endParaRPr lang="en-US"/>
           </a:p>
         </p:txBody>
       </p:sp>
     </p:spTree>
-    <p:extLst>
-      <p:ext uri="{BB962C8B-B14F-4D97-AF65-F5344CB8AC3E}">
-        <p14:creationId xmlns:p14="http://schemas.microsoft.com/office/powerpoint/2010/main" val="2209977519"/>
-      </p:ext>
-    </p:extLst>
   </p:cSld>
   <p:clrMap bg1="lt1" tx1="dk1" bg2="lt2" tx2="dk2" accent1="accent1" accent2="accent2" accent3="accent3" accent4="accent4" accent5="accent5" accent6="accent6" hlink="hlink" folHlink="folHlink"/>
   <p:sldLayoutIdLst>
@@ -2857,7 +2830,7 @@
         <a:spcBef>
           <a:spcPct val="20000"/>
         </a:spcBef>
-        <a:buFont typeface="Arial"/>
+        <a:buFont typeface="Arial" panose="020B0604020202020204"/>
         <a:buChar char="•"/>
         <a:defRPr sz="3200" kern="1200">
           <a:solidFill>
@@ -2872,7 +2845,7 @@
         <a:spcBef>
           <a:spcPct val="20000"/>
         </a:spcBef>
-        <a:buFont typeface="Arial"/>
+        <a:buFont typeface="Arial" panose="020B0604020202020204"/>
         <a:buChar char="–"/>
         <a:defRPr sz="2800" kern="1200">
           <a:solidFill>
@@ -2887,7 +2860,7 @@
         <a:spcBef>
           <a:spcPct val="20000"/>
         </a:spcBef>
-        <a:buFont typeface="Arial"/>
+        <a:buFont typeface="Arial" panose="020B0604020202020204"/>
         <a:buChar char="•"/>
         <a:defRPr sz="2400" kern="1200">
           <a:solidFill>
@@ -2902,7 +2875,7 @@
         <a:spcBef>
           <a:spcPct val="20000"/>
         </a:spcBef>
-        <a:buFont typeface="Arial"/>
+        <a:buFont typeface="Arial" panose="020B0604020202020204"/>
         <a:buChar char="–"/>
         <a:defRPr sz="2000" kern="1200">
           <a:solidFill>
@@ -2917,7 +2890,7 @@
         <a:spcBef>
           <a:spcPct val="20000"/>
         </a:spcBef>
-        <a:buFont typeface="Arial"/>
+        <a:buFont typeface="Arial" panose="020B0604020202020204"/>
         <a:buChar char="»"/>
         <a:defRPr sz="2000" kern="1200">
           <a:solidFill>
@@ -2932,7 +2905,7 @@
         <a:spcBef>
           <a:spcPct val="20000"/>
         </a:spcBef>
-        <a:buFont typeface="Arial"/>
+        <a:buFont typeface="Arial" panose="020B0604020202020204"/>
         <a:buChar char="•"/>
         <a:defRPr sz="2000" kern="1200">
           <a:solidFill>
@@ -2947,7 +2920,7 @@
         <a:spcBef>
           <a:spcPct val="20000"/>
         </a:spcBef>
-        <a:buFont typeface="Arial"/>
+        <a:buFont typeface="Arial" panose="020B0604020202020204"/>
         <a:buChar char="•"/>
         <a:defRPr sz="2000" kern="1200">
           <a:solidFill>
@@ -2962,7 +2935,7 @@
         <a:spcBef>
           <a:spcPct val="20000"/>
         </a:spcBef>
-        <a:buFont typeface="Arial"/>
+        <a:buFont typeface="Arial" panose="020B0604020202020204"/>
         <a:buChar char="•"/>
         <a:defRPr sz="2000" kern="1200">
           <a:solidFill>
@@ -2977,7 +2950,7 @@
         <a:spcBef>
           <a:spcPct val="20000"/>
         </a:spcBef>
-        <a:buFont typeface="Arial"/>
+        <a:buFont typeface="Arial" panose="020B0604020202020204"/>
         <a:buChar char="•"/>
         <a:defRPr sz="2000" kern="1200">
           <a:solidFill>
@@ -3089,7 +3062,7 @@
 </file>
 
 <file path=ppt/slides/slide1.xml><?xml version="1.0" encoding="utf-8"?>
-<p:sld xmlns:a="http://schemas.openxmlformats.org/drawingml/2006/main" xmlns:p="http://schemas.openxmlformats.org/presentationml/2006/main" xmlns:r="http://schemas.openxmlformats.org/officeDocument/2006/relationships">
+<p:sld xmlns:a="http://schemas.openxmlformats.org/drawingml/2006/main" xmlns:r="http://schemas.openxmlformats.org/officeDocument/2006/relationships" xmlns:p="http://schemas.openxmlformats.org/presentationml/2006/main">
   <p:cSld>
     <p:bg>
       <p:bgPr>
@@ -3314,6 +3287,12 @@
               </a:rPr>
               <a:t>NEXUS</a:t>
             </a:r>
+            <a:endParaRPr sz="4600" b="1" i="0">
+              <a:solidFill>
+                <a:srgbClr val="F6F9FC"/>
+              </a:solidFill>
+              <a:latin typeface="Aptos"/>
+            </a:endParaRPr>
           </a:p>
         </p:txBody>
       </p:sp>
@@ -3353,6 +3332,12 @@
               </a:rPr>
               <a:t>GESTÃO</a:t>
             </a:r>
+            <a:endParaRPr sz="2500" b="1" i="0">
+              <a:solidFill>
+                <a:srgbClr val="28D6BE"/>
+              </a:solidFill>
+              <a:latin typeface="Aptos"/>
+            </a:endParaRPr>
           </a:p>
         </p:txBody>
       </p:sp>
@@ -3365,7 +3350,7 @@
         <p:spPr>
           <a:xfrm>
             <a:off x="987552" y="2514600"/>
-            <a:ext cx="6766560" cy="1051560"/>
+            <a:ext cx="6766560" cy="1506855"/>
           </a:xfrm>
           <a:prstGeom prst="rect">
             <a:avLst/>
@@ -3393,6 +3378,38 @@
               <a:t>Um protótipo de sistema para organizar
 informações e rotinas administrativas</a:t>
             </a:r>
+            <a:endParaRPr sz="2300" b="0" i="0">
+              <a:solidFill>
+                <a:srgbClr val="F6F9FC"/>
+              </a:solidFill>
+              <a:latin typeface="Aptos"/>
+            </a:endParaRPr>
+          </a:p>
+          <a:p>
+            <a:pPr algn="l">
+              <a:spcAft>
+                <a:spcPts val="0"/>
+              </a:spcAft>
+            </a:pPr>
+            <a:endParaRPr sz="2300" b="0" i="0">
+              <a:solidFill>
+                <a:srgbClr val="F6F9FC"/>
+              </a:solidFill>
+              <a:latin typeface="Aptos"/>
+            </a:endParaRPr>
+          </a:p>
+          <a:p>
+            <a:pPr algn="l">
+              <a:spcAft>
+                <a:spcPts val="0"/>
+              </a:spcAft>
+            </a:pPr>
+            <a:endParaRPr sz="2300" b="0" i="0">
+              <a:solidFill>
+                <a:srgbClr val="F6F9FC"/>
+              </a:solidFill>
+              <a:latin typeface="Aptos"/>
+            </a:endParaRPr>
           </a:p>
         </p:txBody>
       </p:sp>
@@ -3405,7 +3422,7 @@
         <p:spPr>
           <a:xfrm>
             <a:off x="1005840" y="4114800"/>
-            <a:ext cx="4389120" cy="256032"/>
+            <a:ext cx="4389120" cy="1106805"/>
           </a:xfrm>
           <a:prstGeom prst="rect">
             <a:avLst/>
@@ -3432,6 +3449,131 @@
               </a:rPr>
               <a:t>APRESENTAÇÃO DO PROJETO</a:t>
             </a:r>
+            <a:endParaRPr sz="1100" b="1" i="0">
+              <a:solidFill>
+                <a:srgbClr val="AEBED2"/>
+              </a:solidFill>
+              <a:latin typeface="Aptos"/>
+            </a:endParaRPr>
+          </a:p>
+          <a:p>
+            <a:pPr algn="l">
+              <a:spcAft>
+                <a:spcPts val="0"/>
+              </a:spcAft>
+            </a:pPr>
+            <a:r>
+              <a:rPr lang="en-US" altLang="pt-BR" sz="1100" b="1" i="0">
+                <a:solidFill>
+                  <a:srgbClr val="AEBED2"/>
+                </a:solidFill>
+                <a:latin typeface="Aptos"/>
+              </a:rPr>
+              <a:t>Pedro Henrique Bassi - 04734-071</a:t>
+            </a:r>
+            <a:endParaRPr lang="en-US" altLang="pt-BR" sz="1100" b="1" i="0">
+              <a:solidFill>
+                <a:srgbClr val="AEBED2"/>
+              </a:solidFill>
+              <a:latin typeface="Aptos"/>
+            </a:endParaRPr>
+          </a:p>
+          <a:p>
+            <a:pPr algn="l">
+              <a:spcAft>
+                <a:spcPts val="0"/>
+              </a:spcAft>
+            </a:pPr>
+            <a:r>
+              <a:rPr lang="en-US" altLang="pt-BR" sz="1100" b="1" i="0">
+                <a:solidFill>
+                  <a:srgbClr val="AEBED2"/>
+                </a:solidFill>
+                <a:latin typeface="Aptos"/>
+              </a:rPr>
+              <a:t>Jo</a:t>
+            </a:r>
+            <a:r>
+              <a:rPr lang="en-US" altLang="en-US" sz="1100" b="1" i="0">
+                <a:solidFill>
+                  <a:srgbClr val="AEBED2"/>
+                </a:solidFill>
+                <a:latin typeface="Aptos"/>
+              </a:rPr>
+              <a:t>ã</a:t>
+            </a:r>
+            <a:r>
+              <a:rPr lang="en-US" altLang="pt-BR" sz="1100" b="1" i="0">
+                <a:solidFill>
+                  <a:srgbClr val="AEBED2"/>
+                </a:solidFill>
+                <a:latin typeface="Aptos"/>
+              </a:rPr>
+              <a:t>o Paulo Silva - 04724-079</a:t>
+            </a:r>
+            <a:endParaRPr lang="en-US" altLang="pt-BR" sz="1100" b="1" i="0">
+              <a:solidFill>
+                <a:srgbClr val="AEBED2"/>
+              </a:solidFill>
+              <a:latin typeface="Aptos"/>
+            </a:endParaRPr>
+          </a:p>
+          <a:p>
+            <a:pPr algn="l">
+              <a:spcAft>
+                <a:spcPts val="0"/>
+              </a:spcAft>
+            </a:pPr>
+            <a:r>
+              <a:rPr lang="en-US" altLang="pt-BR" sz="1100" b="1" i="0">
+                <a:solidFill>
+                  <a:srgbClr val="AEBED2"/>
+                </a:solidFill>
+                <a:latin typeface="Aptos"/>
+              </a:rPr>
+              <a:t>Felipe Sperli Neto - 04724-054</a:t>
+            </a:r>
+            <a:endParaRPr lang="en-US" altLang="pt-BR" sz="1100" b="1" i="0">
+              <a:solidFill>
+                <a:srgbClr val="AEBED2"/>
+              </a:solidFill>
+              <a:latin typeface="Aptos"/>
+            </a:endParaRPr>
+          </a:p>
+          <a:p>
+            <a:pPr algn="l">
+              <a:spcAft>
+                <a:spcPts val="0"/>
+              </a:spcAft>
+            </a:pPr>
+            <a:r>
+              <a:rPr lang="en-US" altLang="pt-BR" sz="1100" b="1" i="0">
+                <a:solidFill>
+                  <a:srgbClr val="AEBED2"/>
+                </a:solidFill>
+                <a:latin typeface="Aptos"/>
+              </a:rPr>
+              <a:t>Christian Hugo - 04724-098</a:t>
+            </a:r>
+            <a:endParaRPr lang="en-US" altLang="pt-BR" sz="1100" b="1" i="0">
+              <a:solidFill>
+                <a:srgbClr val="AEBED2"/>
+              </a:solidFill>
+              <a:latin typeface="Aptos"/>
+            </a:endParaRPr>
+          </a:p>
+          <a:p>
+            <a:pPr algn="l">
+              <a:spcAft>
+                <a:spcPts val="0"/>
+              </a:spcAft>
+            </a:pPr>
+            <a:endParaRPr lang="en-US" altLang="pt-BR" sz="1100" b="1" i="0">
+              <a:solidFill>
+                <a:srgbClr val="AEBED2"/>
+              </a:solidFill>
+              <a:latin typeface="Aptos"/>
+            </a:endParaRPr>
           </a:p>
         </p:txBody>
       </p:sp>
@@ -3443,7 +3585,7 @@
         </p:nvSpPr>
         <p:spPr>
           <a:xfrm>
-            <a:off x="987552" y="4617720"/>
+            <a:off x="1051687" y="5314950"/>
             <a:ext cx="1874519" cy="502920"/>
           </a:xfrm>
           <a:prstGeom prst="roundRect">
@@ -3486,7 +3628,7 @@
         </p:nvSpPr>
         <p:spPr>
           <a:xfrm>
-            <a:off x="1051560" y="4745736"/>
+            <a:off x="1051560" y="5458841"/>
             <a:ext cx="1737360" cy="201168"/>
           </a:xfrm>
           <a:prstGeom prst="rect">
@@ -3514,6 +3656,12 @@
               </a:rPr>
               <a:t>WEB + API REST</a:t>
             </a:r>
+            <a:endParaRPr sz="1100" b="1" i="0">
+              <a:solidFill>
+                <a:srgbClr val="28D6BE"/>
+              </a:solidFill>
+              <a:latin typeface="Aptos"/>
+            </a:endParaRPr>
           </a:p>
         </p:txBody>
       </p:sp>
@@ -3553,6 +3701,12 @@
               </a:rPr>
               <a:t>Projeto acadêmico • Java • Spring Boot • Thymeleaf</a:t>
             </a:r>
+            <a:endParaRPr sz="1200" b="0" i="0">
+              <a:solidFill>
+                <a:srgbClr val="AEBED2"/>
+              </a:solidFill>
+              <a:latin typeface="Aptos"/>
+            </a:endParaRPr>
           </a:p>
         </p:txBody>
       </p:sp>
@@ -3592,6 +3746,12 @@
               </a:rPr>
               <a:t>01</a:t>
             </a:r>
+            <a:endParaRPr sz="1000" b="1" i="0">
+              <a:solidFill>
+                <a:srgbClr val="AEBED2"/>
+              </a:solidFill>
+              <a:latin typeface="Aptos"/>
+            </a:endParaRPr>
           </a:p>
         </p:txBody>
       </p:sp>
@@ -3604,7 +3764,7 @@
 </file>
 
 <file path=ppt/slides/slide10.xml><?xml version="1.0" encoding="utf-8"?>
-<p:sld xmlns:a="http://schemas.openxmlformats.org/drawingml/2006/main" xmlns:p="http://schemas.openxmlformats.org/presentationml/2006/main" xmlns:r="http://schemas.openxmlformats.org/officeDocument/2006/relationships">
+<p:sld xmlns:a="http://schemas.openxmlformats.org/drawingml/2006/main" xmlns:r="http://schemas.openxmlformats.org/officeDocument/2006/relationships" xmlns:p="http://schemas.openxmlformats.org/presentationml/2006/main">
   <p:cSld>
     <p:bg>
       <p:bgPr>
@@ -3657,6 +3817,12 @@
               </a:rPr>
               <a:t>09 • PRÓXIMOS PASSOS</a:t>
             </a:r>
+            <a:endParaRPr sz="1000" b="1" i="0">
+              <a:solidFill>
+                <a:srgbClr val="28D6BE"/>
+              </a:solidFill>
+              <a:latin typeface="Aptos"/>
+            </a:endParaRPr>
           </a:p>
         </p:txBody>
       </p:sp>
@@ -3696,6 +3862,12 @@
               </a:rPr>
               <a:t>Como o Nexus pode evoluir</a:t>
             </a:r>
+            <a:endParaRPr sz="2900" b="1" i="0">
+              <a:solidFill>
+                <a:srgbClr val="F6F9FC"/>
+              </a:solidFill>
+              <a:latin typeface="Aptos"/>
+            </a:endParaRPr>
           </a:p>
         </p:txBody>
       </p:sp>
@@ -3735,6 +3907,12 @@
               </a:rPr>
               <a:t>Sugestões para transformar a demonstração em uma aplicação mais integrada.</a:t>
             </a:r>
+            <a:endParaRPr sz="1300" b="0" i="0">
+              <a:solidFill>
+                <a:srgbClr val="AEBED2"/>
+              </a:solidFill>
+              <a:latin typeface="Aptos"/>
+            </a:endParaRPr>
           </a:p>
         </p:txBody>
       </p:sp>
@@ -3817,6 +3995,12 @@
               </a:rPr>
               <a:t>10</a:t>
             </a:r>
+            <a:endParaRPr sz="1000" b="1" i="0">
+              <a:solidFill>
+                <a:srgbClr val="AEBED2"/>
+              </a:solidFill>
+              <a:latin typeface="Aptos"/>
+            </a:endParaRPr>
           </a:p>
         </p:txBody>
       </p:sp>
@@ -3899,6 +4083,12 @@
               </a:rPr>
               <a:t>01</a:t>
             </a:r>
+            <a:endParaRPr sz="1000" b="1" i="0">
+              <a:solidFill>
+                <a:srgbClr val="0C162A"/>
+              </a:solidFill>
+              <a:latin typeface="Aptos"/>
+            </a:endParaRPr>
           </a:p>
         </p:txBody>
       </p:sp>
@@ -3938,6 +4128,12 @@
               </a:rPr>
               <a:t>Integração Web ↔ API</a:t>
             </a:r>
+            <a:endParaRPr sz="1500" b="1" i="0">
+              <a:solidFill>
+                <a:srgbClr val="F6F9FC"/>
+              </a:solidFill>
+              <a:latin typeface="Aptos"/>
+            </a:endParaRPr>
           </a:p>
         </p:txBody>
       </p:sp>
@@ -3977,6 +4173,12 @@
               </a:rPr>
               <a:t>Consumir os endpoints da API a partir da interface Web.</a:t>
             </a:r>
+            <a:endParaRPr sz="1200" b="0" i="0">
+              <a:solidFill>
+                <a:srgbClr val="AEBED2"/>
+              </a:solidFill>
+              <a:latin typeface="Aptos"/>
+            </a:endParaRPr>
           </a:p>
         </p:txBody>
       </p:sp>
@@ -4102,6 +4304,12 @@
               </a:rPr>
               <a:t>02</a:t>
             </a:r>
+            <a:endParaRPr sz="1000" b="1" i="0">
+              <a:solidFill>
+                <a:srgbClr val="0C162A"/>
+              </a:solidFill>
+              <a:latin typeface="Aptos"/>
+            </a:endParaRPr>
           </a:p>
         </p:txBody>
       </p:sp>
@@ -4141,6 +4349,12 @@
               </a:rPr>
               <a:t>Persistência consistente</a:t>
             </a:r>
+            <a:endParaRPr sz="1500" b="1" i="0">
+              <a:solidFill>
+                <a:srgbClr val="F6F9FC"/>
+              </a:solidFill>
+              <a:latin typeface="Aptos"/>
+            </a:endParaRPr>
           </a:p>
         </p:txBody>
       </p:sp>
@@ -4180,6 +4394,12 @@
               </a:rPr>
               <a:t>Definir banco e estratégia de dados compartilhada quando necessário.</a:t>
             </a:r>
+            <a:endParaRPr sz="1200" b="0" i="0">
+              <a:solidFill>
+                <a:srgbClr val="AEBED2"/>
+              </a:solidFill>
+              <a:latin typeface="Aptos"/>
+            </a:endParaRPr>
           </a:p>
         </p:txBody>
       </p:sp>
@@ -4305,6 +4525,12 @@
               </a:rPr>
               <a:t>03</a:t>
             </a:r>
+            <a:endParaRPr sz="1000" b="1" i="0">
+              <a:solidFill>
+                <a:srgbClr val="0C162A"/>
+              </a:solidFill>
+              <a:latin typeface="Aptos"/>
+            </a:endParaRPr>
           </a:p>
         </p:txBody>
       </p:sp>
@@ -4344,6 +4570,12 @@
               </a:rPr>
               <a:t>Validação de formulários</a:t>
             </a:r>
+            <a:endParaRPr sz="1500" b="1" i="0">
+              <a:solidFill>
+                <a:srgbClr val="F6F9FC"/>
+              </a:solidFill>
+              <a:latin typeface="Aptos"/>
+            </a:endParaRPr>
           </a:p>
         </p:txBody>
       </p:sp>
@@ -4383,6 +4615,12 @@
               </a:rPr>
               <a:t>Validar campos obrigatórios e apresentar mensagens claras.</a:t>
             </a:r>
+            <a:endParaRPr sz="1200" b="0" i="0">
+              <a:solidFill>
+                <a:srgbClr val="AEBED2"/>
+              </a:solidFill>
+              <a:latin typeface="Aptos"/>
+            </a:endParaRPr>
           </a:p>
         </p:txBody>
       </p:sp>
@@ -4508,6 +4746,12 @@
               </a:rPr>
               <a:t>04</a:t>
             </a:r>
+            <a:endParaRPr sz="1000" b="1" i="0">
+              <a:solidFill>
+                <a:srgbClr val="0C162A"/>
+              </a:solidFill>
+              <a:latin typeface="Aptos"/>
+            </a:endParaRPr>
           </a:p>
         </p:txBody>
       </p:sp>
@@ -4547,6 +4791,12 @@
               </a:rPr>
               <a:t>Testes e segurança</a:t>
             </a:r>
+            <a:endParaRPr sz="1500" b="1" i="0">
+              <a:solidFill>
+                <a:srgbClr val="F6F9FC"/>
+              </a:solidFill>
+              <a:latin typeface="Aptos"/>
+            </a:endParaRPr>
           </a:p>
         </p:txBody>
       </p:sp>
@@ -4586,6 +4836,12 @@
               </a:rPr>
               <a:t>Criar testes e planejar autenticação/autorização conforme o escopo.</a:t>
             </a:r>
+            <a:endParaRPr sz="1200" b="0" i="0">
+              <a:solidFill>
+                <a:srgbClr val="AEBED2"/>
+              </a:solidFill>
+              <a:latin typeface="Aptos"/>
+            </a:endParaRPr>
           </a:p>
         </p:txBody>
       </p:sp>
@@ -4625,6 +4881,12 @@
               </a:rPr>
               <a:t>NEXUS GESTÃO  •  PROJETO ACADÊMICO</a:t>
             </a:r>
+            <a:endParaRPr sz="900" b="0" i="0">
+              <a:solidFill>
+                <a:srgbClr val="AEBED2"/>
+              </a:solidFill>
+              <a:latin typeface="Aptos"/>
+            </a:endParaRPr>
           </a:p>
         </p:txBody>
       </p:sp>
@@ -4637,7 +4899,7 @@
 </file>
 
 <file path=ppt/slides/slide11.xml><?xml version="1.0" encoding="utf-8"?>
-<p:sld xmlns:a="http://schemas.openxmlformats.org/drawingml/2006/main" xmlns:p="http://schemas.openxmlformats.org/presentationml/2006/main" xmlns:r="http://schemas.openxmlformats.org/officeDocument/2006/relationships">
+<p:sld xmlns:a="http://schemas.openxmlformats.org/drawingml/2006/main" xmlns:r="http://schemas.openxmlformats.org/officeDocument/2006/relationships" xmlns:p="http://schemas.openxmlformats.org/presentationml/2006/main">
   <p:cSld>
     <p:bg>
       <p:bgPr>
@@ -4819,6 +5081,12 @@
               </a:rPr>
               <a:t>NEXUS GESTÃO</a:t>
             </a:r>
+            <a:endParaRPr sz="3300" b="1" i="0">
+              <a:solidFill>
+                <a:srgbClr val="F6F9FC"/>
+              </a:solidFill>
+              <a:latin typeface="Aptos"/>
+            </a:endParaRPr>
           </a:p>
         </p:txBody>
       </p:sp>
@@ -4859,6 +5127,12 @@
               <a:t>Organização hoje.
 Integração como próximo passo.</a:t>
             </a:r>
+            <a:endParaRPr sz="2700" b="1" i="0">
+              <a:solidFill>
+                <a:srgbClr val="28D6BE"/>
+              </a:solidFill>
+              <a:latin typeface="Aptos"/>
+            </a:endParaRPr>
           </a:p>
         </p:txBody>
       </p:sp>
@@ -4898,6 +5172,12 @@
               </a:rPr>
               <a:t>O projeto apresenta uma base de interface administrativa e uma API separada, com oportunidades claras de evolução técnica.</a:t>
             </a:r>
+            <a:endParaRPr sz="1700" b="0" i="0">
+              <a:solidFill>
+                <a:srgbClr val="F6F9FC"/>
+              </a:solidFill>
+              <a:latin typeface="Aptos"/>
+            </a:endParaRPr>
           </a:p>
         </p:txBody>
       </p:sp>
@@ -4980,6 +5260,12 @@
               </a:rPr>
               <a:t>OBRIGADO!</a:t>
             </a:r>
+            <a:endParaRPr sz="1200" b="1" i="0">
+              <a:solidFill>
+                <a:srgbClr val="28D6BE"/>
+              </a:solidFill>
+              <a:latin typeface="Aptos"/>
+            </a:endParaRPr>
           </a:p>
         </p:txBody>
       </p:sp>
@@ -5019,6 +5305,12 @@
               </a:rPr>
               <a:t>Perguntas?</a:t>
             </a:r>
+            <a:endParaRPr sz="1400" b="1" i="0">
+              <a:solidFill>
+                <a:srgbClr val="F6F9FC"/>
+              </a:solidFill>
+              <a:latin typeface="Aptos"/>
+            </a:endParaRPr>
           </a:p>
         </p:txBody>
       </p:sp>
@@ -5058,6 +5350,12 @@
               </a:rPr>
               <a:t>NEXUS GESTÃO  •  PROJETO ACADÊMICO</a:t>
             </a:r>
+            <a:endParaRPr sz="900" b="0" i="0">
+              <a:solidFill>
+                <a:srgbClr val="AEBED2"/>
+              </a:solidFill>
+              <a:latin typeface="Aptos"/>
+            </a:endParaRPr>
           </a:p>
         </p:txBody>
       </p:sp>
@@ -5070,7 +5368,7 @@
 </file>
 
 <file path=ppt/slides/slide2.xml><?xml version="1.0" encoding="utf-8"?>
-<p:sld xmlns:a="http://schemas.openxmlformats.org/drawingml/2006/main" xmlns:p="http://schemas.openxmlformats.org/presentationml/2006/main" xmlns:r="http://schemas.openxmlformats.org/officeDocument/2006/relationships">
+<p:sld xmlns:a="http://schemas.openxmlformats.org/drawingml/2006/main" xmlns:r="http://schemas.openxmlformats.org/officeDocument/2006/relationships" xmlns:p="http://schemas.openxmlformats.org/presentationml/2006/main">
   <p:cSld>
     <p:bg>
       <p:bgPr>
@@ -5123,6 +5421,12 @@
               </a:rPr>
               <a:t>01 • CONTEXTO</a:t>
             </a:r>
+            <a:endParaRPr sz="1000" b="1" i="0">
+              <a:solidFill>
+                <a:srgbClr val="28D6BE"/>
+              </a:solidFill>
+              <a:latin typeface="Aptos"/>
+            </a:endParaRPr>
           </a:p>
         </p:txBody>
       </p:sp>
@@ -5162,6 +5466,12 @@
               </a:rPr>
               <a:t>Por que o Nexus Gestão?</a:t>
             </a:r>
+            <a:endParaRPr sz="2900" b="1" i="0">
+              <a:solidFill>
+                <a:srgbClr val="F6F9FC"/>
+              </a:solidFill>
+              <a:latin typeface="Aptos"/>
+            </a:endParaRPr>
           </a:p>
         </p:txBody>
       </p:sp>
@@ -5201,6 +5511,12 @@
               </a:rPr>
               <a:t>A proposta é reunir diferentes áreas administrativas em uma interface clara e consistente.</a:t>
             </a:r>
+            <a:endParaRPr sz="1300" b="0" i="0">
+              <a:solidFill>
+                <a:srgbClr val="AEBED2"/>
+              </a:solidFill>
+              <a:latin typeface="Aptos"/>
+            </a:endParaRPr>
           </a:p>
         </p:txBody>
       </p:sp>
@@ -5283,6 +5599,12 @@
               </a:rPr>
               <a:t>02</a:t>
             </a:r>
+            <a:endParaRPr sz="1000" b="1" i="0">
+              <a:solidFill>
+                <a:srgbClr val="AEBED2"/>
+              </a:solidFill>
+              <a:latin typeface="Aptos"/>
+            </a:endParaRPr>
           </a:p>
         </p:txBody>
       </p:sp>
@@ -5408,6 +5730,12 @@
               </a:rPr>
               <a:t>01</a:t>
             </a:r>
+            <a:endParaRPr sz="2200" b="1" i="0">
+              <a:solidFill>
+                <a:srgbClr val="28D6BE"/>
+              </a:solidFill>
+              <a:latin typeface="Aptos"/>
+            </a:endParaRPr>
           </a:p>
         </p:txBody>
       </p:sp>
@@ -5447,6 +5775,12 @@
               </a:rPr>
               <a:t>Informação dispersa</a:t>
             </a:r>
+            <a:endParaRPr sz="1600" b="1" i="0">
+              <a:solidFill>
+                <a:srgbClr val="F6F9FC"/>
+              </a:solidFill>
+              <a:latin typeface="Aptos"/>
+            </a:endParaRPr>
           </a:p>
         </p:txBody>
       </p:sp>
@@ -5486,6 +5820,12 @@
               </a:rPr>
               <a:t>Dados de pessoas, contas, veículos e serviços podem ficar separados em controles diferentes.</a:t>
             </a:r>
+            <a:endParaRPr sz="1200" b="0" i="0">
+              <a:solidFill>
+                <a:srgbClr val="AEBED2"/>
+              </a:solidFill>
+              <a:latin typeface="Aptos"/>
+            </a:endParaRPr>
           </a:p>
         </p:txBody>
       </p:sp>
@@ -5611,6 +5951,12 @@
               </a:rPr>
               <a:t>02</a:t>
             </a:r>
+            <a:endParaRPr sz="2200" b="1" i="0">
+              <a:solidFill>
+                <a:srgbClr val="5EBEFF"/>
+              </a:solidFill>
+              <a:latin typeface="Aptos"/>
+            </a:endParaRPr>
           </a:p>
         </p:txBody>
       </p:sp>
@@ -5650,6 +5996,12 @@
               </a:rPr>
               <a:t>Rotina mais organizada</a:t>
             </a:r>
+            <a:endParaRPr sz="1600" b="1" i="0">
+              <a:solidFill>
+                <a:srgbClr val="F6F9FC"/>
+              </a:solidFill>
+              <a:latin typeface="Aptos"/>
+            </a:endParaRPr>
           </a:p>
         </p:txBody>
       </p:sp>
@@ -5689,6 +6041,12 @@
               </a:rPr>
               <a:t>Uma navegação única ajuda o usuário a localizar a área de trabalho com menos etapas.</a:t>
             </a:r>
+            <a:endParaRPr sz="1200" b="0" i="0">
+              <a:solidFill>
+                <a:srgbClr val="AEBED2"/>
+              </a:solidFill>
+              <a:latin typeface="Aptos"/>
+            </a:endParaRPr>
           </a:p>
         </p:txBody>
       </p:sp>
@@ -5814,6 +6172,12 @@
               </a:rPr>
               <a:t>03</a:t>
             </a:r>
+            <a:endParaRPr sz="2200" b="1" i="0">
+              <a:solidFill>
+                <a:srgbClr val="FFC25C"/>
+              </a:solidFill>
+              <a:latin typeface="Aptos"/>
+            </a:endParaRPr>
           </a:p>
         </p:txBody>
       </p:sp>
@@ -5853,6 +6217,12 @@
               </a:rPr>
               <a:t>Visão rápida</a:t>
             </a:r>
+            <a:endParaRPr sz="1600" b="1" i="0">
+              <a:solidFill>
+                <a:srgbClr val="F6F9FC"/>
+              </a:solidFill>
+              <a:latin typeface="Aptos"/>
+            </a:endParaRPr>
           </a:p>
         </p:txBody>
       </p:sp>
@@ -5892,6 +6262,12 @@
               </a:rPr>
               <a:t>O painel inicial oferece um resumo visual dos principais módulos do sistema.</a:t>
             </a:r>
+            <a:endParaRPr sz="1200" b="0" i="0">
+              <a:solidFill>
+                <a:srgbClr val="AEBED2"/>
+              </a:solidFill>
+              <a:latin typeface="Aptos"/>
+            </a:endParaRPr>
           </a:p>
         </p:txBody>
       </p:sp>
@@ -5931,6 +6307,12 @@
               </a:rPr>
               <a:t>Objetivo central</a:t>
             </a:r>
+            <a:endParaRPr sz="1600" b="1" i="0">
+              <a:solidFill>
+                <a:srgbClr val="28D6BE"/>
+              </a:solidFill>
+              <a:latin typeface="Aptos"/>
+            </a:endParaRPr>
           </a:p>
         </p:txBody>
       </p:sp>
@@ -5970,6 +6352,12 @@
               </a:rPr>
               <a:t>Construir uma base visual e técnica que possa evoluir para uma solução administrativa integrada.</a:t>
             </a:r>
+            <a:endParaRPr sz="2100" b="1" i="0">
+              <a:solidFill>
+                <a:srgbClr val="F6F9FC"/>
+              </a:solidFill>
+              <a:latin typeface="Aptos"/>
+            </a:endParaRPr>
           </a:p>
         </p:txBody>
       </p:sp>
@@ -6009,6 +6397,12 @@
               </a:rPr>
               <a:t>NEXUS GESTÃO  •  PROJETO ACADÊMICO</a:t>
             </a:r>
+            <a:endParaRPr sz="900" b="0" i="0">
+              <a:solidFill>
+                <a:srgbClr val="AEBED2"/>
+              </a:solidFill>
+              <a:latin typeface="Aptos"/>
+            </a:endParaRPr>
           </a:p>
         </p:txBody>
       </p:sp>
@@ -6021,7 +6415,7 @@
 </file>
 
 <file path=ppt/slides/slide3.xml><?xml version="1.0" encoding="utf-8"?>
-<p:sld xmlns:a="http://schemas.openxmlformats.org/drawingml/2006/main" xmlns:p="http://schemas.openxmlformats.org/presentationml/2006/main" xmlns:r="http://schemas.openxmlformats.org/officeDocument/2006/relationships">
+<p:sld xmlns:a="http://schemas.openxmlformats.org/drawingml/2006/main" xmlns:r="http://schemas.openxmlformats.org/officeDocument/2006/relationships" xmlns:p="http://schemas.openxmlformats.org/presentationml/2006/main">
   <p:cSld>
     <p:bg>
       <p:bgPr>
@@ -6074,6 +6468,12 @@
               </a:rPr>
               <a:t>02 • VISÃO GERAL</a:t>
             </a:r>
+            <a:endParaRPr sz="1000" b="1" i="0">
+              <a:solidFill>
+                <a:srgbClr val="28D6BE"/>
+              </a:solidFill>
+              <a:latin typeface="Aptos"/>
+            </a:endParaRPr>
           </a:p>
         </p:txBody>
       </p:sp>
@@ -6113,6 +6513,12 @@
               </a:rPr>
               <a:t>O que é o Nexus Gestão?</a:t>
             </a:r>
+            <a:endParaRPr sz="2900" b="1" i="0">
+              <a:solidFill>
+                <a:srgbClr val="F6F9FC"/>
+              </a:solidFill>
+              <a:latin typeface="Aptos"/>
+            </a:endParaRPr>
           </a:p>
         </p:txBody>
       </p:sp>
@@ -6152,6 +6558,12 @@
               </a:rPr>
               <a:t>Um protótipo web com módulos administrativos e uma estrutura de API desenvolvida em Spring Boot.</a:t>
             </a:r>
+            <a:endParaRPr sz="1300" b="0" i="0">
+              <a:solidFill>
+                <a:srgbClr val="AEBED2"/>
+              </a:solidFill>
+              <a:latin typeface="Aptos"/>
+            </a:endParaRPr>
           </a:p>
         </p:txBody>
       </p:sp>
@@ -6234,6 +6646,12 @@
               </a:rPr>
               <a:t>03</a:t>
             </a:r>
+            <a:endParaRPr sz="1000" b="1" i="0">
+              <a:solidFill>
+                <a:srgbClr val="AEBED2"/>
+              </a:solidFill>
+              <a:latin typeface="Aptos"/>
+            </a:endParaRPr>
           </a:p>
         </p:txBody>
       </p:sp>
@@ -6316,6 +6734,12 @@
               </a:rPr>
               <a:t>INTERFACE WEB</a:t>
             </a:r>
+            <a:endParaRPr sz="1400" b="1" i="0">
+              <a:solidFill>
+                <a:srgbClr val="28D6BE"/>
+              </a:solidFill>
+              <a:latin typeface="Aptos"/>
+            </a:endParaRPr>
           </a:p>
         </p:txBody>
       </p:sp>
@@ -6355,6 +6779,12 @@
               </a:rPr>
               <a:t>Dashboard e páginas de gestão</a:t>
             </a:r>
+            <a:endParaRPr sz="2300" b="1" i="0">
+              <a:solidFill>
+                <a:srgbClr val="F6F9FC"/>
+              </a:solidFill>
+              <a:latin typeface="Aptos"/>
+            </a:endParaRPr>
           </a:p>
         </p:txBody>
       </p:sp>
@@ -6375,7 +6805,7 @@
           <a:noFill/>
         </p:spPr>
         <p:txBody>
-          <a:bodyPr wrap="square" lIns="73152" rIns="45720" tIns="36576" bIns="27432">
+          <a:bodyPr wrap="square" lIns="73152" tIns="36576" rIns="45720" bIns="27432">
             <a:spAutoFit/>
           </a:bodyPr>
           <a:lstStyle/>
@@ -6524,6 +6954,12 @@
               </a:rPr>
               <a:t>API REST</a:t>
             </a:r>
+            <a:endParaRPr sz="1400" b="1" i="0">
+              <a:solidFill>
+                <a:srgbClr val="5EBEFF"/>
+              </a:solidFill>
+              <a:latin typeface="Aptos"/>
+            </a:endParaRPr>
           </a:p>
         </p:txBody>
       </p:sp>
@@ -6563,6 +6999,12 @@
               </a:rPr>
               <a:t>Camada de serviços</a:t>
             </a:r>
+            <a:endParaRPr sz="2200" b="1" i="0">
+              <a:solidFill>
+                <a:srgbClr val="F6F9FC"/>
+              </a:solidFill>
+              <a:latin typeface="Aptos"/>
+            </a:endParaRPr>
           </a:p>
         </p:txBody>
       </p:sp>
@@ -6583,7 +7025,7 @@
           <a:noFill/>
         </p:spPr>
         <p:txBody>
-          <a:bodyPr wrap="square" lIns="73152" rIns="45720" tIns="36576" bIns="27432">
+          <a:bodyPr wrap="square" lIns="73152" tIns="36576" rIns="45720" bIns="27432">
             <a:spAutoFit/>
           </a:bodyPr>
           <a:lstStyle/>
@@ -6673,6 +7115,12 @@
               </a:rPr>
               <a:t>Nota técnica: na versão descrita no repositório, Web e API são projetos independentes e usam bancos H2 separados.</a:t>
             </a:r>
+            <a:endParaRPr sz="1100" b="0" i="1">
+              <a:solidFill>
+                <a:srgbClr val="FFC25C"/>
+              </a:solidFill>
+              <a:latin typeface="Aptos"/>
+            </a:endParaRPr>
           </a:p>
         </p:txBody>
       </p:sp>
@@ -6712,6 +7160,12 @@
               </a:rPr>
               <a:t>NEXUS GESTÃO  •  PROJETO ACADÊMICO</a:t>
             </a:r>
+            <a:endParaRPr sz="900" b="0" i="0">
+              <a:solidFill>
+                <a:srgbClr val="AEBED2"/>
+              </a:solidFill>
+              <a:latin typeface="Aptos"/>
+            </a:endParaRPr>
           </a:p>
         </p:txBody>
       </p:sp>
@@ -6724,7 +7178,7 @@
 </file>
 
 <file path=ppt/slides/slide4.xml><?xml version="1.0" encoding="utf-8"?>
-<p:sld xmlns:a="http://schemas.openxmlformats.org/drawingml/2006/main" xmlns:p="http://schemas.openxmlformats.org/presentationml/2006/main" xmlns:r="http://schemas.openxmlformats.org/officeDocument/2006/relationships">
+<p:sld xmlns:a="http://schemas.openxmlformats.org/drawingml/2006/main" xmlns:r="http://schemas.openxmlformats.org/officeDocument/2006/relationships" xmlns:p="http://schemas.openxmlformats.org/presentationml/2006/main">
   <p:cSld>
     <p:bg>
       <p:bgPr>
@@ -6777,6 +7231,12 @@
               </a:rPr>
               <a:t>03 • MÓDULOS</a:t>
             </a:r>
+            <a:endParaRPr sz="1000" b="1" i="0">
+              <a:solidFill>
+                <a:srgbClr val="28D6BE"/>
+              </a:solidFill>
+              <a:latin typeface="Aptos"/>
+            </a:endParaRPr>
           </a:p>
         </p:txBody>
       </p:sp>
@@ -6816,6 +7276,12 @@
               </a:rPr>
               <a:t>Quatro áreas em uma mesma experiência</a:t>
             </a:r>
+            <a:endParaRPr sz="2900" b="1" i="0">
+              <a:solidFill>
+                <a:srgbClr val="F6F9FC"/>
+              </a:solidFill>
+              <a:latin typeface="Aptos"/>
+            </a:endParaRPr>
           </a:p>
         </p:txBody>
       </p:sp>
@@ -6855,6 +7321,12 @@
               </a:rPr>
               <a:t>Cada módulo representa uma categoria de informação administrativa.</a:t>
             </a:r>
+            <a:endParaRPr sz="1300" b="0" i="0">
+              <a:solidFill>
+                <a:srgbClr val="AEBED2"/>
+              </a:solidFill>
+              <a:latin typeface="Aptos"/>
+            </a:endParaRPr>
           </a:p>
         </p:txBody>
       </p:sp>
@@ -6937,6 +7409,12 @@
               </a:rPr>
               <a:t>04</a:t>
             </a:r>
+            <a:endParaRPr sz="1000" b="1" i="0">
+              <a:solidFill>
+                <a:srgbClr val="AEBED2"/>
+              </a:solidFill>
+              <a:latin typeface="Aptos"/>
+            </a:endParaRPr>
           </a:p>
         </p:txBody>
       </p:sp>
@@ -7062,6 +7540,12 @@
               </a:rPr>
               <a:t>01</a:t>
             </a:r>
+            <a:endParaRPr sz="2200" b="1" i="0">
+              <a:solidFill>
+                <a:srgbClr val="28D6BE"/>
+              </a:solidFill>
+              <a:latin typeface="Aptos"/>
+            </a:endParaRPr>
           </a:p>
         </p:txBody>
       </p:sp>
@@ -7101,6 +7585,12 @@
               </a:rPr>
               <a:t>Funcionários</a:t>
             </a:r>
+            <a:endParaRPr sz="1600" b="1" i="0">
+              <a:solidFill>
+                <a:srgbClr val="F6F9FC"/>
+              </a:solidFill>
+              <a:latin typeface="Aptos"/>
+            </a:endParaRPr>
           </a:p>
         </p:txBody>
       </p:sp>
@@ -7140,6 +7630,12 @@
               </a:rPr>
               <a:t>Organização de informações relacionadas à equipe.</a:t>
             </a:r>
+            <a:endParaRPr sz="1200" b="0" i="0">
+              <a:solidFill>
+                <a:srgbClr val="AEBED2"/>
+              </a:solidFill>
+              <a:latin typeface="Aptos"/>
+            </a:endParaRPr>
           </a:p>
         </p:txBody>
       </p:sp>
@@ -7265,6 +7761,12 @@
               </a:rPr>
               <a:t>02</a:t>
             </a:r>
+            <a:endParaRPr sz="2200" b="1" i="0">
+              <a:solidFill>
+                <a:srgbClr val="FFC25C"/>
+              </a:solidFill>
+              <a:latin typeface="Aptos"/>
+            </a:endParaRPr>
           </a:p>
         </p:txBody>
       </p:sp>
@@ -7304,6 +7806,12 @@
               </a:rPr>
               <a:t>Contas do mês</a:t>
             </a:r>
+            <a:endParaRPr sz="1600" b="1" i="0">
+              <a:solidFill>
+                <a:srgbClr val="F6F9FC"/>
+              </a:solidFill>
+              <a:latin typeface="Aptos"/>
+            </a:endParaRPr>
           </a:p>
         </p:txBody>
       </p:sp>
@@ -7343,6 +7851,12 @@
               </a:rPr>
               <a:t>Área dedicada ao acompanhamento de contas e despesas.</a:t>
             </a:r>
+            <a:endParaRPr sz="1200" b="0" i="0">
+              <a:solidFill>
+                <a:srgbClr val="AEBED2"/>
+              </a:solidFill>
+              <a:latin typeface="Aptos"/>
+            </a:endParaRPr>
           </a:p>
         </p:txBody>
       </p:sp>
@@ -7468,6 +7982,12 @@
               </a:rPr>
               <a:t>03</a:t>
             </a:r>
+            <a:endParaRPr sz="2200" b="1" i="0">
+              <a:solidFill>
+                <a:srgbClr val="5EBEFF"/>
+              </a:solidFill>
+              <a:latin typeface="Aptos"/>
+            </a:endParaRPr>
           </a:p>
         </p:txBody>
       </p:sp>
@@ -7507,6 +8027,12 @@
               </a:rPr>
               <a:t>Veículos</a:t>
             </a:r>
+            <a:endParaRPr sz="1600" b="1" i="0">
+              <a:solidFill>
+                <a:srgbClr val="F6F9FC"/>
+              </a:solidFill>
+              <a:latin typeface="Aptos"/>
+            </a:endParaRPr>
           </a:p>
         </p:txBody>
       </p:sp>
@@ -7546,6 +8072,12 @@
               </a:rPr>
               <a:t>Espaço para centralizar informações de veículos.</a:t>
             </a:r>
+            <a:endParaRPr sz="1200" b="0" i="0">
+              <a:solidFill>
+                <a:srgbClr val="AEBED2"/>
+              </a:solidFill>
+              <a:latin typeface="Aptos"/>
+            </a:endParaRPr>
           </a:p>
         </p:txBody>
       </p:sp>
@@ -7671,6 +8203,12 @@
               </a:rPr>
               <a:t>04</a:t>
             </a:r>
+            <a:endParaRPr sz="2200" b="1" i="0">
+              <a:solidFill>
+                <a:srgbClr val="74E0A6"/>
+              </a:solidFill>
+              <a:latin typeface="Aptos"/>
+            </a:endParaRPr>
           </a:p>
         </p:txBody>
       </p:sp>
@@ -7710,6 +8248,12 @@
               </a:rPr>
               <a:t>Serviços</a:t>
             </a:r>
+            <a:endParaRPr sz="1600" b="1" i="0">
+              <a:solidFill>
+                <a:srgbClr val="F6F9FC"/>
+              </a:solidFill>
+              <a:latin typeface="Aptos"/>
+            </a:endParaRPr>
           </a:p>
         </p:txBody>
       </p:sp>
@@ -7749,6 +8293,12 @@
               </a:rPr>
               <a:t>Área para registrar e consultar informações de serviços.</a:t>
             </a:r>
+            <a:endParaRPr sz="1200" b="0" i="0">
+              <a:solidFill>
+                <a:srgbClr val="AEBED2"/>
+              </a:solidFill>
+              <a:latin typeface="Aptos"/>
+            </a:endParaRPr>
           </a:p>
         </p:txBody>
       </p:sp>
@@ -7788,6 +8338,12 @@
               </a:rPr>
               <a:t>Os detalhes de campos e operações podem ser ajustados conforme os requisitos finais do grupo.</a:t>
             </a:r>
+            <a:endParaRPr sz="1100" b="0" i="1">
+              <a:solidFill>
+                <a:srgbClr val="AEBED2"/>
+              </a:solidFill>
+              <a:latin typeface="Aptos"/>
+            </a:endParaRPr>
           </a:p>
         </p:txBody>
       </p:sp>
@@ -7827,6 +8383,12 @@
               </a:rPr>
               <a:t>NEXUS GESTÃO  •  PROJETO ACADÊMICO</a:t>
             </a:r>
+            <a:endParaRPr sz="900" b="0" i="0">
+              <a:solidFill>
+                <a:srgbClr val="AEBED2"/>
+              </a:solidFill>
+              <a:latin typeface="Aptos"/>
+            </a:endParaRPr>
           </a:p>
         </p:txBody>
       </p:sp>
@@ -7839,7 +8401,7 @@
 </file>
 
 <file path=ppt/slides/slide5.xml><?xml version="1.0" encoding="utf-8"?>
-<p:sld xmlns:a="http://schemas.openxmlformats.org/drawingml/2006/main" xmlns:p="http://schemas.openxmlformats.org/presentationml/2006/main" xmlns:r="http://schemas.openxmlformats.org/officeDocument/2006/relationships">
+<p:sld xmlns:a="http://schemas.openxmlformats.org/drawingml/2006/main" xmlns:r="http://schemas.openxmlformats.org/officeDocument/2006/relationships" xmlns:p="http://schemas.openxmlformats.org/presentationml/2006/main">
   <p:cSld>
     <p:bg>
       <p:bgPr>
@@ -7892,6 +8454,12 @@
               </a:rPr>
               <a:t>04 • INTERFACE</a:t>
             </a:r>
+            <a:endParaRPr sz="1000" b="1" i="0">
+              <a:solidFill>
+                <a:srgbClr val="28D6BE"/>
+              </a:solidFill>
+              <a:latin typeface="Aptos"/>
+            </a:endParaRPr>
           </a:p>
         </p:txBody>
       </p:sp>
@@ -7931,6 +8499,12 @@
               </a:rPr>
               <a:t>Dashboard: ponto de partida</a:t>
             </a:r>
+            <a:endParaRPr sz="2900" b="1" i="0">
+              <a:solidFill>
+                <a:srgbClr val="F6F9FC"/>
+              </a:solidFill>
+              <a:latin typeface="Aptos"/>
+            </a:endParaRPr>
           </a:p>
         </p:txBody>
       </p:sp>
@@ -7970,6 +8544,12 @@
               </a:rPr>
               <a:t>O painel resume as áreas do sistema e orienta o usuário para a próxima ação.</a:t>
             </a:r>
+            <a:endParaRPr sz="1300" b="0" i="0">
+              <a:solidFill>
+                <a:srgbClr val="AEBED2"/>
+              </a:solidFill>
+              <a:latin typeface="Aptos"/>
+            </a:endParaRPr>
           </a:p>
         </p:txBody>
       </p:sp>
@@ -8052,6 +8632,12 @@
               </a:rPr>
               <a:t>05</a:t>
             </a:r>
+            <a:endParaRPr sz="1000" b="1" i="0">
+              <a:solidFill>
+                <a:srgbClr val="AEBED2"/>
+              </a:solidFill>
+              <a:latin typeface="Aptos"/>
+            </a:endParaRPr>
           </a:p>
         </p:txBody>
       </p:sp>
@@ -8177,6 +8763,12 @@
               </a:rPr>
               <a:t>N</a:t>
             </a:r>
+            <a:endParaRPr sz="2400" b="1" i="0">
+              <a:solidFill>
+                <a:srgbClr val="28D6BE"/>
+              </a:solidFill>
+              <a:latin typeface="Aptos"/>
+            </a:endParaRPr>
           </a:p>
         </p:txBody>
       </p:sp>
@@ -8216,6 +8808,12 @@
               </a:rPr>
               <a:t>Início</a:t>
             </a:r>
+            <a:endParaRPr sz="900" b="1" i="0">
+              <a:solidFill>
+                <a:srgbClr val="F6F9FC"/>
+              </a:solidFill>
+              <a:latin typeface="Aptos"/>
+            </a:endParaRPr>
           </a:p>
         </p:txBody>
       </p:sp>
@@ -8255,6 +8853,12 @@
               </a:rPr>
               <a:t>Funcionários</a:t>
             </a:r>
+            <a:endParaRPr sz="900" b="0" i="0">
+              <a:solidFill>
+                <a:srgbClr val="AEBED2"/>
+              </a:solidFill>
+              <a:latin typeface="Aptos"/>
+            </a:endParaRPr>
           </a:p>
         </p:txBody>
       </p:sp>
@@ -8294,6 +8898,12 @@
               </a:rPr>
               <a:t>Contas</a:t>
             </a:r>
+            <a:endParaRPr sz="900" b="0" i="0">
+              <a:solidFill>
+                <a:srgbClr val="AEBED2"/>
+              </a:solidFill>
+              <a:latin typeface="Aptos"/>
+            </a:endParaRPr>
           </a:p>
         </p:txBody>
       </p:sp>
@@ -8333,6 +8943,12 @@
               </a:rPr>
               <a:t>Veículos</a:t>
             </a:r>
+            <a:endParaRPr sz="900" b="0" i="0">
+              <a:solidFill>
+                <a:srgbClr val="AEBED2"/>
+              </a:solidFill>
+              <a:latin typeface="Aptos"/>
+            </a:endParaRPr>
           </a:p>
         </p:txBody>
       </p:sp>
@@ -8372,6 +8988,12 @@
               </a:rPr>
               <a:t>Serviços</a:t>
             </a:r>
+            <a:endParaRPr sz="900" b="0" i="0">
+              <a:solidFill>
+                <a:srgbClr val="AEBED2"/>
+              </a:solidFill>
+              <a:latin typeface="Aptos"/>
+            </a:endParaRPr>
           </a:p>
         </p:txBody>
       </p:sp>
@@ -8411,6 +9033,12 @@
               </a:rPr>
               <a:t>Visão geral</a:t>
             </a:r>
+            <a:endParaRPr sz="1800" b="1" i="0">
+              <a:solidFill>
+                <a:srgbClr val="19273D"/>
+              </a:solidFill>
+              <a:latin typeface="Aptos"/>
+            </a:endParaRPr>
           </a:p>
         </p:txBody>
       </p:sp>
@@ -8450,6 +9078,12 @@
               </a:rPr>
               <a:t>Resumo da gestão</a:t>
             </a:r>
+            <a:endParaRPr sz="1000" b="0" i="0">
+              <a:solidFill>
+                <a:srgbClr val="5A6C80"/>
+              </a:solidFill>
+              <a:latin typeface="Aptos"/>
+            </a:endParaRPr>
           </a:p>
         </p:txBody>
       </p:sp>
@@ -8575,6 +9209,12 @@
               </a:rPr>
               <a:t>12</a:t>
             </a:r>
+            <a:endParaRPr sz="2200" b="1" i="0">
+              <a:solidFill>
+                <a:srgbClr val="19273D"/>
+              </a:solidFill>
+              <a:latin typeface="Aptos"/>
+            </a:endParaRPr>
           </a:p>
         </p:txBody>
       </p:sp>
@@ -8614,6 +9254,12 @@
               </a:rPr>
               <a:t>Funcionários</a:t>
             </a:r>
+            <a:endParaRPr sz="900" b="0" i="0">
+              <a:solidFill>
+                <a:srgbClr val="5A6C80"/>
+              </a:solidFill>
+              <a:latin typeface="Aptos"/>
+            </a:endParaRPr>
           </a:p>
         </p:txBody>
       </p:sp>
@@ -8739,6 +9385,12 @@
               </a:rPr>
               <a:t>08</a:t>
             </a:r>
+            <a:endParaRPr sz="2200" b="1" i="0">
+              <a:solidFill>
+                <a:srgbClr val="19273D"/>
+              </a:solidFill>
+              <a:latin typeface="Aptos"/>
+            </a:endParaRPr>
           </a:p>
         </p:txBody>
       </p:sp>
@@ -8778,6 +9430,12 @@
               </a:rPr>
               <a:t>Contas</a:t>
             </a:r>
+            <a:endParaRPr sz="900" b="0" i="0">
+              <a:solidFill>
+                <a:srgbClr val="5A6C80"/>
+              </a:solidFill>
+              <a:latin typeface="Aptos"/>
+            </a:endParaRPr>
           </a:p>
         </p:txBody>
       </p:sp>
@@ -8903,6 +9561,12 @@
               </a:rPr>
               <a:t>05</a:t>
             </a:r>
+            <a:endParaRPr sz="2200" b="1" i="0">
+              <a:solidFill>
+                <a:srgbClr val="19273D"/>
+              </a:solidFill>
+              <a:latin typeface="Aptos"/>
+            </a:endParaRPr>
           </a:p>
         </p:txBody>
       </p:sp>
@@ -8942,6 +9606,12 @@
               </a:rPr>
               <a:t>Veículos</a:t>
             </a:r>
+            <a:endParaRPr sz="900" b="0" i="0">
+              <a:solidFill>
+                <a:srgbClr val="5A6C80"/>
+              </a:solidFill>
+              <a:latin typeface="Aptos"/>
+            </a:endParaRPr>
           </a:p>
         </p:txBody>
       </p:sp>
@@ -9024,6 +9694,12 @@
               </a:rPr>
               <a:t>Acesso rápido aos módulos</a:t>
             </a:r>
+            <a:endParaRPr sz="1200" b="1" i="0">
+              <a:solidFill>
+                <a:srgbClr val="19273D"/>
+              </a:solidFill>
+              <a:latin typeface="Aptos"/>
+            </a:endParaRPr>
           </a:p>
         </p:txBody>
       </p:sp>
@@ -9063,6 +9739,12 @@
               </a:rPr>
               <a:t>Funcionários   •   Contas   •   Veículos   •   Serviços</a:t>
             </a:r>
+            <a:endParaRPr sz="900" b="0" i="0">
+              <a:solidFill>
+                <a:srgbClr val="5A6C80"/>
+              </a:solidFill>
+              <a:latin typeface="Aptos"/>
+            </a:endParaRPr>
           </a:p>
         </p:txBody>
       </p:sp>
@@ -9102,6 +9784,12 @@
               </a:rPr>
               <a:t>EXEMPLO ILUSTRATIVO</a:t>
             </a:r>
+            <a:endParaRPr sz="800" b="1" i="0">
+              <a:solidFill>
+                <a:srgbClr val="5A6C80"/>
+              </a:solidFill>
+              <a:latin typeface="Aptos"/>
+            </a:endParaRPr>
           </a:p>
         </p:txBody>
       </p:sp>
@@ -9227,6 +9915,12 @@
               </a:rPr>
               <a:t>Hierarquia visual</a:t>
             </a:r>
+            <a:endParaRPr sz="1600" b="1" i="0">
+              <a:solidFill>
+                <a:srgbClr val="F6F9FC"/>
+              </a:solidFill>
+              <a:latin typeface="Aptos"/>
+            </a:endParaRPr>
           </a:p>
         </p:txBody>
       </p:sp>
@@ -9266,6 +9960,12 @@
               </a:rPr>
               <a:t>Títulos e indicadores organizam a leitura.</a:t>
             </a:r>
+            <a:endParaRPr sz="1200" b="0" i="0">
+              <a:solidFill>
+                <a:srgbClr val="AEBED2"/>
+              </a:solidFill>
+              <a:latin typeface="Aptos"/>
+            </a:endParaRPr>
           </a:p>
         </p:txBody>
       </p:sp>
@@ -9391,6 +10091,12 @@
               </a:rPr>
               <a:t>Navegação</a:t>
             </a:r>
+            <a:endParaRPr sz="1600" b="1" i="0">
+              <a:solidFill>
+                <a:srgbClr val="F6F9FC"/>
+              </a:solidFill>
+              <a:latin typeface="Aptos"/>
+            </a:endParaRPr>
           </a:p>
         </p:txBody>
       </p:sp>
@@ -9430,6 +10136,12 @@
               </a:rPr>
               <a:t>Menu lateral mantém os módulos acessíveis.</a:t>
             </a:r>
+            <a:endParaRPr sz="1200" b="0" i="0">
+              <a:solidFill>
+                <a:srgbClr val="AEBED2"/>
+              </a:solidFill>
+              <a:latin typeface="Aptos"/>
+            </a:endParaRPr>
           </a:p>
         </p:txBody>
       </p:sp>
@@ -9555,6 +10267,12 @@
               </a:rPr>
               <a:t>Consistência</a:t>
             </a:r>
+            <a:endParaRPr sz="1600" b="1" i="0">
+              <a:solidFill>
+                <a:srgbClr val="F6F9FC"/>
+              </a:solidFill>
+              <a:latin typeface="Aptos"/>
+            </a:endParaRPr>
           </a:p>
         </p:txBody>
       </p:sp>
@@ -9594,6 +10312,12 @@
               </a:rPr>
               <a:t>Padrões de layout podem ser reutilizados.</a:t>
             </a:r>
+            <a:endParaRPr sz="1200" b="0" i="0">
+              <a:solidFill>
+                <a:srgbClr val="AEBED2"/>
+              </a:solidFill>
+              <a:latin typeface="Aptos"/>
+            </a:endParaRPr>
           </a:p>
         </p:txBody>
       </p:sp>
@@ -9633,6 +10357,12 @@
               </a:rPr>
               <a:t>NEXUS GESTÃO  •  PROJETO ACADÊMICO</a:t>
             </a:r>
+            <a:endParaRPr sz="900" b="0" i="0">
+              <a:solidFill>
+                <a:srgbClr val="AEBED2"/>
+              </a:solidFill>
+              <a:latin typeface="Aptos"/>
+            </a:endParaRPr>
           </a:p>
         </p:txBody>
       </p:sp>
@@ -9645,7 +10375,7 @@
 </file>
 
 <file path=ppt/slides/slide6.xml><?xml version="1.0" encoding="utf-8"?>
-<p:sld xmlns:a="http://schemas.openxmlformats.org/drawingml/2006/main" xmlns:p="http://schemas.openxmlformats.org/presentationml/2006/main" xmlns:r="http://schemas.openxmlformats.org/officeDocument/2006/relationships">
+<p:sld xmlns:a="http://schemas.openxmlformats.org/drawingml/2006/main" xmlns:r="http://schemas.openxmlformats.org/officeDocument/2006/relationships" xmlns:p="http://schemas.openxmlformats.org/presentationml/2006/main">
   <p:cSld>
     <p:bg>
       <p:bgPr>
@@ -9698,6 +10428,12 @@
               </a:rPr>
               <a:t>05 • ARQUITETURA</a:t>
             </a:r>
+            <a:endParaRPr sz="1000" b="1" i="0">
+              <a:solidFill>
+                <a:srgbClr val="28D6BE"/>
+              </a:solidFill>
+              <a:latin typeface="Aptos"/>
+            </a:endParaRPr>
           </a:p>
         </p:txBody>
       </p:sp>
@@ -9737,6 +10473,12 @@
               </a:rPr>
               <a:t>Como a solução está organizada</a:t>
             </a:r>
+            <a:endParaRPr sz="2900" b="1" i="0">
+              <a:solidFill>
+                <a:srgbClr val="F6F9FC"/>
+              </a:solidFill>
+              <a:latin typeface="Aptos"/>
+            </a:endParaRPr>
           </a:p>
         </p:txBody>
       </p:sp>
@@ -9776,6 +10518,12 @@
               </a:rPr>
               <a:t>Separação em dois projetos permite desenvolver interface e API de forma independente.</a:t>
             </a:r>
+            <a:endParaRPr sz="1300" b="0" i="0">
+              <a:solidFill>
+                <a:srgbClr val="AEBED2"/>
+              </a:solidFill>
+              <a:latin typeface="Aptos"/>
+            </a:endParaRPr>
           </a:p>
         </p:txBody>
       </p:sp>
@@ -9858,6 +10606,12 @@
               </a:rPr>
               <a:t>06</a:t>
             </a:r>
+            <a:endParaRPr sz="1000" b="1" i="0">
+              <a:solidFill>
+                <a:srgbClr val="AEBED2"/>
+              </a:solidFill>
+              <a:latin typeface="Aptos"/>
+            </a:endParaRPr>
           </a:p>
         </p:txBody>
       </p:sp>
@@ -9940,6 +10694,12 @@
               </a:rPr>
               <a:t>USUÁRIO</a:t>
             </a:r>
+            <a:endParaRPr sz="1700" b="1" i="0">
+              <a:solidFill>
+                <a:srgbClr val="F6F9FC"/>
+              </a:solidFill>
+              <a:latin typeface="Aptos"/>
+            </a:endParaRPr>
           </a:p>
         </p:txBody>
       </p:sp>
@@ -9979,6 +10739,12 @@
               </a:rPr>
               <a:t>Navegador</a:t>
             </a:r>
+            <a:endParaRPr sz="1100" b="0" i="0">
+              <a:solidFill>
+                <a:srgbClr val="AEBED2"/>
+              </a:solidFill>
+              <a:latin typeface="Aptos"/>
+            </a:endParaRPr>
           </a:p>
         </p:txBody>
       </p:sp>
@@ -10061,6 +10827,12 @@
               </a:rPr>
               <a:t>WEB</a:t>
             </a:r>
+            <a:endParaRPr sz="1800" b="1" i="0">
+              <a:solidFill>
+                <a:srgbClr val="28D6BE"/>
+              </a:solidFill>
+              <a:latin typeface="Aptos"/>
+            </a:endParaRPr>
           </a:p>
         </p:txBody>
       </p:sp>
@@ -10100,6 +10872,12 @@
               </a:rPr>
               <a:t>Spring Boot + Thymeleaf</a:t>
             </a:r>
+            <a:endParaRPr sz="1100" b="0" i="0">
+              <a:solidFill>
+                <a:srgbClr val="F6F9FC"/>
+              </a:solidFill>
+              <a:latin typeface="Aptos"/>
+            </a:endParaRPr>
           </a:p>
         </p:txBody>
       </p:sp>
@@ -10139,6 +10917,12 @@
               </a:rPr>
               <a:t>Porta 8080</a:t>
             </a:r>
+            <a:endParaRPr sz="1000" b="0" i="0">
+              <a:solidFill>
+                <a:srgbClr val="AEBED2"/>
+              </a:solidFill>
+              <a:latin typeface="Aptos"/>
+            </a:endParaRPr>
           </a:p>
         </p:txBody>
       </p:sp>
@@ -10221,6 +11005,12 @@
               </a:rPr>
               <a:t>API REST</a:t>
             </a:r>
+            <a:endParaRPr sz="1800" b="1" i="0">
+              <a:solidFill>
+                <a:srgbClr val="5EBEFF"/>
+              </a:solidFill>
+              <a:latin typeface="Aptos"/>
+            </a:endParaRPr>
           </a:p>
         </p:txBody>
       </p:sp>
@@ -10260,6 +11050,12 @@
               </a:rPr>
               <a:t>Spring Boot</a:t>
             </a:r>
+            <a:endParaRPr sz="1100" b="0" i="0">
+              <a:solidFill>
+                <a:srgbClr val="F6F9FC"/>
+              </a:solidFill>
+              <a:latin typeface="Aptos"/>
+            </a:endParaRPr>
           </a:p>
         </p:txBody>
       </p:sp>
@@ -10299,6 +11095,12 @@
               </a:rPr>
               <a:t>Porta 8081</a:t>
             </a:r>
+            <a:endParaRPr sz="1000" b="0" i="0">
+              <a:solidFill>
+                <a:srgbClr val="AEBED2"/>
+              </a:solidFill>
+              <a:latin typeface="Aptos"/>
+            </a:endParaRPr>
           </a:p>
         </p:txBody>
       </p:sp>
@@ -10408,6 +11210,12 @@
               </a:rPr>
               <a:t>Banco H2 do projeto Web</a:t>
             </a:r>
+            <a:endParaRPr sz="1100" b="1" i="0">
+              <a:solidFill>
+                <a:srgbClr val="F6F9FC"/>
+              </a:solidFill>
+              <a:latin typeface="Aptos"/>
+            </a:endParaRPr>
           </a:p>
         </p:txBody>
       </p:sp>
@@ -10447,6 +11255,12 @@
               </a:rPr>
               <a:t>Banco H2 do projeto API</a:t>
             </a:r>
+            <a:endParaRPr sz="1100" b="1" i="0">
+              <a:solidFill>
+                <a:srgbClr val="F6F9FC"/>
+              </a:solidFill>
+              <a:latin typeface="Aptos"/>
+            </a:endParaRPr>
           </a:p>
         </p:txBody>
       </p:sp>
@@ -10486,6 +11300,12 @@
               </a:rPr>
               <a:t>Importante</a:t>
             </a:r>
+            <a:endParaRPr sz="1400" b="1" i="0">
+              <a:solidFill>
+                <a:srgbClr val="FFC25C"/>
+              </a:solidFill>
+              <a:latin typeface="Aptos"/>
+            </a:endParaRPr>
           </a:p>
         </p:txBody>
       </p:sp>
@@ -10525,6 +11345,12 @@
               </a:rPr>
               <a:t>Nesta versão, os bancos são separados e a comunicação entre Web e API ainda precisa ser confirmada/implementada.</a:t>
             </a:r>
+            <a:endParaRPr sz="1500" b="0" i="0">
+              <a:solidFill>
+                <a:srgbClr val="F6F9FC"/>
+              </a:solidFill>
+              <a:latin typeface="Aptos"/>
+            </a:endParaRPr>
           </a:p>
         </p:txBody>
       </p:sp>
@@ -10564,6 +11390,12 @@
               </a:rPr>
               <a:t>NEXUS GESTÃO  •  PROJETO ACADÊMICO</a:t>
             </a:r>
+            <a:endParaRPr sz="900" b="0" i="0">
+              <a:solidFill>
+                <a:srgbClr val="AEBED2"/>
+              </a:solidFill>
+              <a:latin typeface="Aptos"/>
+            </a:endParaRPr>
           </a:p>
         </p:txBody>
       </p:sp>
@@ -10576,7 +11408,7 @@
 </file>
 
 <file path=ppt/slides/slide7.xml><?xml version="1.0" encoding="utf-8"?>
-<p:sld xmlns:a="http://schemas.openxmlformats.org/drawingml/2006/main" xmlns:p="http://schemas.openxmlformats.org/presentationml/2006/main" xmlns:r="http://schemas.openxmlformats.org/officeDocument/2006/relationships">
+<p:sld xmlns:a="http://schemas.openxmlformats.org/drawingml/2006/main" xmlns:r="http://schemas.openxmlformats.org/officeDocument/2006/relationships" xmlns:p="http://schemas.openxmlformats.org/presentationml/2006/main">
   <p:cSld>
     <p:bg>
       <p:bgPr>
@@ -10629,6 +11461,12 @@
               </a:rPr>
               <a:t>06 • TECNOLOGIAS</a:t>
             </a:r>
+            <a:endParaRPr sz="1000" b="1" i="0">
+              <a:solidFill>
+                <a:srgbClr val="28D6BE"/>
+              </a:solidFill>
+              <a:latin typeface="Aptos"/>
+            </a:endParaRPr>
           </a:p>
         </p:txBody>
       </p:sp>
@@ -10668,6 +11506,12 @@
               </a:rPr>
               <a:t>Ferramentas utilizadas</a:t>
             </a:r>
+            <a:endParaRPr sz="2900" b="1" i="0">
+              <a:solidFill>
+                <a:srgbClr val="F6F9FC"/>
+              </a:solidFill>
+              <a:latin typeface="Aptos"/>
+            </a:endParaRPr>
           </a:p>
         </p:txBody>
       </p:sp>
@@ -10707,6 +11551,12 @@
               </a:rPr>
               <a:t>Cada tecnologia contribui para uma parte específica do sistema.</a:t>
             </a:r>
+            <a:endParaRPr sz="1300" b="0" i="0">
+              <a:solidFill>
+                <a:srgbClr val="AEBED2"/>
+              </a:solidFill>
+              <a:latin typeface="Aptos"/>
+            </a:endParaRPr>
           </a:p>
         </p:txBody>
       </p:sp>
@@ -10789,6 +11639,12 @@
               </a:rPr>
               <a:t>07</a:t>
             </a:r>
+            <a:endParaRPr sz="1000" b="1" i="0">
+              <a:solidFill>
+                <a:srgbClr val="AEBED2"/>
+              </a:solidFill>
+              <a:latin typeface="Aptos"/>
+            </a:endParaRPr>
           </a:p>
         </p:txBody>
       </p:sp>
@@ -10871,6 +11727,12 @@
               </a:rPr>
               <a:t>JAVA</a:t>
             </a:r>
+            <a:endParaRPr sz="1500" b="1" i="0">
+              <a:solidFill>
+                <a:srgbClr val="28D6BE"/>
+              </a:solidFill>
+              <a:latin typeface="Aptos"/>
+            </a:endParaRPr>
           </a:p>
         </p:txBody>
       </p:sp>
@@ -10910,6 +11772,12 @@
               </a:rPr>
               <a:t>Linguagem principal</a:t>
             </a:r>
+            <a:endParaRPr sz="1200" b="0" i="0">
+              <a:solidFill>
+                <a:srgbClr val="F6F9FC"/>
+              </a:solidFill>
+              <a:latin typeface="Aptos"/>
+            </a:endParaRPr>
           </a:p>
         </p:txBody>
       </p:sp>
@@ -10992,6 +11860,12 @@
               </a:rPr>
               <a:t>SPRING BOOT</a:t>
             </a:r>
+            <a:endParaRPr sz="1500" b="1" i="0">
+              <a:solidFill>
+                <a:srgbClr val="5EBEFF"/>
+              </a:solidFill>
+              <a:latin typeface="Aptos"/>
+            </a:endParaRPr>
           </a:p>
         </p:txBody>
       </p:sp>
@@ -11031,6 +11905,12 @@
               </a:rPr>
               <a:t>Estrutura dos projetos</a:t>
             </a:r>
+            <a:endParaRPr sz="1200" b="0" i="0">
+              <a:solidFill>
+                <a:srgbClr val="F6F9FC"/>
+              </a:solidFill>
+              <a:latin typeface="Aptos"/>
+            </a:endParaRPr>
           </a:p>
         </p:txBody>
       </p:sp>
@@ -11113,6 +11993,12 @@
               </a:rPr>
               <a:t>THYMELEAF</a:t>
             </a:r>
+            <a:endParaRPr sz="1500" b="1" i="0">
+              <a:solidFill>
+                <a:srgbClr val="FFC25C"/>
+              </a:solidFill>
+              <a:latin typeface="Aptos"/>
+            </a:endParaRPr>
           </a:p>
         </p:txBody>
       </p:sp>
@@ -11152,6 +12038,12 @@
               </a:rPr>
               <a:t>Renderização de páginas HTML</a:t>
             </a:r>
+            <a:endParaRPr sz="1200" b="0" i="0">
+              <a:solidFill>
+                <a:srgbClr val="F6F9FC"/>
+              </a:solidFill>
+              <a:latin typeface="Aptos"/>
+            </a:endParaRPr>
           </a:p>
         </p:txBody>
       </p:sp>
@@ -11234,6 +12126,12 @@
               </a:rPr>
               <a:t>HTML + CSS</a:t>
             </a:r>
+            <a:endParaRPr sz="1500" b="1" i="0">
+              <a:solidFill>
+                <a:srgbClr val="74E0A6"/>
+              </a:solidFill>
+              <a:latin typeface="Aptos"/>
+            </a:endParaRPr>
           </a:p>
         </p:txBody>
       </p:sp>
@@ -11273,6 +12171,12 @@
               </a:rPr>
               <a:t>Estrutura e aparência da interface</a:t>
             </a:r>
+            <a:endParaRPr sz="1200" b="0" i="0">
+              <a:solidFill>
+                <a:srgbClr val="F6F9FC"/>
+              </a:solidFill>
+              <a:latin typeface="Aptos"/>
+            </a:endParaRPr>
           </a:p>
         </p:txBody>
       </p:sp>
@@ -11355,6 +12259,12 @@
               </a:rPr>
               <a:t>H2</a:t>
             </a:r>
+            <a:endParaRPr sz="1500" b="1" i="0">
+              <a:solidFill>
+                <a:srgbClr val="28D6BE"/>
+              </a:solidFill>
+              <a:latin typeface="Aptos"/>
+            </a:endParaRPr>
           </a:p>
         </p:txBody>
       </p:sp>
@@ -11394,6 +12304,12 @@
               </a:rPr>
               <a:t>Banco de dados em memória para desenvolvimento</a:t>
             </a:r>
+            <a:endParaRPr sz="1200" b="0" i="0">
+              <a:solidFill>
+                <a:srgbClr val="F6F9FC"/>
+              </a:solidFill>
+              <a:latin typeface="Aptos"/>
+            </a:endParaRPr>
           </a:p>
         </p:txBody>
       </p:sp>
@@ -11476,6 +12392,12 @@
               </a:rPr>
               <a:t>MAVEN</a:t>
             </a:r>
+            <a:endParaRPr sz="1500" b="1" i="0">
+              <a:solidFill>
+                <a:srgbClr val="5EBEFF"/>
+              </a:solidFill>
+              <a:latin typeface="Aptos"/>
+            </a:endParaRPr>
           </a:p>
         </p:txBody>
       </p:sp>
@@ -11515,6 +12437,12 @@
               </a:rPr>
               <a:t>Gerenciamento de dependências e execução</a:t>
             </a:r>
+            <a:endParaRPr sz="1200" b="0" i="0">
+              <a:solidFill>
+                <a:srgbClr val="F6F9FC"/>
+              </a:solidFill>
+              <a:latin typeface="Aptos"/>
+            </a:endParaRPr>
           </a:p>
         </p:txBody>
       </p:sp>
@@ -11554,6 +12482,12 @@
               </a:rPr>
               <a:t>O README do repositório recomenda Java 17+ e Maven para executar os projetos localmente.</a:t>
             </a:r>
+            <a:endParaRPr sz="1100" b="0" i="1">
+              <a:solidFill>
+                <a:srgbClr val="AEBED2"/>
+              </a:solidFill>
+              <a:latin typeface="Aptos"/>
+            </a:endParaRPr>
           </a:p>
         </p:txBody>
       </p:sp>
@@ -11593,6 +12527,12 @@
               </a:rPr>
               <a:t>NEXUS GESTÃO  •  PROJETO ACADÊMICO</a:t>
             </a:r>
+            <a:endParaRPr sz="900" b="0" i="0">
+              <a:solidFill>
+                <a:srgbClr val="AEBED2"/>
+              </a:solidFill>
+              <a:latin typeface="Aptos"/>
+            </a:endParaRPr>
           </a:p>
         </p:txBody>
       </p:sp>
@@ -11605,7 +12545,7 @@
 </file>
 
 <file path=ppt/slides/slide8.xml><?xml version="1.0" encoding="utf-8"?>
-<p:sld xmlns:a="http://schemas.openxmlformats.org/drawingml/2006/main" xmlns:p="http://schemas.openxmlformats.org/presentationml/2006/main" xmlns:r="http://schemas.openxmlformats.org/officeDocument/2006/relationships">
+<p:sld xmlns:a="http://schemas.openxmlformats.org/drawingml/2006/main" xmlns:r="http://schemas.openxmlformats.org/officeDocument/2006/relationships" xmlns:p="http://schemas.openxmlformats.org/presentationml/2006/main">
   <p:cSld>
     <p:bg>
       <p:bgPr>
@@ -11658,6 +12598,12 @@
               </a:rPr>
               <a:t>07 • FLUXO DE USO</a:t>
             </a:r>
+            <a:endParaRPr sz="1000" b="1" i="0">
+              <a:solidFill>
+                <a:srgbClr val="28D6BE"/>
+              </a:solidFill>
+              <a:latin typeface="Aptos"/>
+            </a:endParaRPr>
           </a:p>
         </p:txBody>
       </p:sp>
@@ -11697,6 +12643,12 @@
               </a:rPr>
               <a:t>Da navegação à informação</a:t>
             </a:r>
+            <a:endParaRPr sz="2900" b="1" i="0">
+              <a:solidFill>
+                <a:srgbClr val="F6F9FC"/>
+              </a:solidFill>
+              <a:latin typeface="Aptos"/>
+            </a:endParaRPr>
           </a:p>
         </p:txBody>
       </p:sp>
@@ -11736,6 +12688,12 @@
               </a:rPr>
               <a:t>Fluxo conceitual de interação na interface Web.</a:t>
             </a:r>
+            <a:endParaRPr sz="1300" b="0" i="0">
+              <a:solidFill>
+                <a:srgbClr val="AEBED2"/>
+              </a:solidFill>
+              <a:latin typeface="Aptos"/>
+            </a:endParaRPr>
           </a:p>
         </p:txBody>
       </p:sp>
@@ -11818,6 +12776,12 @@
               </a:rPr>
               <a:t>08</a:t>
             </a:r>
+            <a:endParaRPr sz="1000" b="1" i="0">
+              <a:solidFill>
+                <a:srgbClr val="AEBED2"/>
+              </a:solidFill>
+              <a:latin typeface="Aptos"/>
+            </a:endParaRPr>
           </a:p>
         </p:txBody>
       </p:sp>
@@ -11900,6 +12864,12 @@
               </a:rPr>
               <a:t>01</a:t>
             </a:r>
+            <a:endParaRPr sz="2000" b="1" i="0">
+              <a:solidFill>
+                <a:srgbClr val="28D6BE"/>
+              </a:solidFill>
+              <a:latin typeface="Aptos"/>
+            </a:endParaRPr>
           </a:p>
         </p:txBody>
       </p:sp>
@@ -11939,6 +12909,12 @@
               </a:rPr>
               <a:t>Abrir o sistema</a:t>
             </a:r>
+            <a:endParaRPr sz="1600" b="1" i="0">
+              <a:solidFill>
+                <a:srgbClr val="F6F9FC"/>
+              </a:solidFill>
+              <a:latin typeface="Aptos"/>
+            </a:endParaRPr>
           </a:p>
         </p:txBody>
       </p:sp>
@@ -11978,6 +12954,12 @@
               </a:rPr>
               <a:t>Usuário acessa a aplicação local pelo navegador.</a:t>
             </a:r>
+            <a:endParaRPr sz="1100" b="0" i="0">
+              <a:solidFill>
+                <a:srgbClr val="AEBED2"/>
+              </a:solidFill>
+              <a:latin typeface="Aptos"/>
+            </a:endParaRPr>
           </a:p>
         </p:txBody>
       </p:sp>
@@ -12095,6 +13077,12 @@
               </a:rPr>
               <a:t>02</a:t>
             </a:r>
+            <a:endParaRPr sz="2000" b="1" i="0">
+              <a:solidFill>
+                <a:srgbClr val="5EBEFF"/>
+              </a:solidFill>
+              <a:latin typeface="Aptos"/>
+            </a:endParaRPr>
           </a:p>
         </p:txBody>
       </p:sp>
@@ -12134,6 +13122,12 @@
               </a:rPr>
               <a:t>Escolher um módulo</a:t>
             </a:r>
+            <a:endParaRPr sz="1600" b="1" i="0">
+              <a:solidFill>
+                <a:srgbClr val="F6F9FC"/>
+              </a:solidFill>
+              <a:latin typeface="Aptos"/>
+            </a:endParaRPr>
           </a:p>
         </p:txBody>
       </p:sp>
@@ -12173,6 +13167,12 @@
               </a:rPr>
               <a:t>Menu lateral direciona para a área desejada.</a:t>
             </a:r>
+            <a:endParaRPr sz="1100" b="0" i="0">
+              <a:solidFill>
+                <a:srgbClr val="AEBED2"/>
+              </a:solidFill>
+              <a:latin typeface="Aptos"/>
+            </a:endParaRPr>
           </a:p>
         </p:txBody>
       </p:sp>
@@ -12290,6 +13290,12 @@
               </a:rPr>
               <a:t>03</a:t>
             </a:r>
+            <a:endParaRPr sz="2000" b="1" i="0">
+              <a:solidFill>
+                <a:srgbClr val="28D6BE"/>
+              </a:solidFill>
+              <a:latin typeface="Aptos"/>
+            </a:endParaRPr>
           </a:p>
         </p:txBody>
       </p:sp>
@@ -12329,6 +13335,12 @@
               </a:rPr>
               <a:t>Consultar ou preencher</a:t>
             </a:r>
+            <a:endParaRPr sz="1600" b="1" i="0">
+              <a:solidFill>
+                <a:srgbClr val="F6F9FC"/>
+              </a:solidFill>
+              <a:latin typeface="Aptos"/>
+            </a:endParaRPr>
           </a:p>
         </p:txBody>
       </p:sp>
@@ -12368,6 +13380,12 @@
               </a:rPr>
               <a:t>A tela apresenta campos e informações do módulo.</a:t>
             </a:r>
+            <a:endParaRPr sz="1100" b="0" i="0">
+              <a:solidFill>
+                <a:srgbClr val="AEBED2"/>
+              </a:solidFill>
+              <a:latin typeface="Aptos"/>
+            </a:endParaRPr>
           </a:p>
         </p:txBody>
       </p:sp>
@@ -12485,6 +13503,12 @@
               </a:rPr>
               <a:t>04</a:t>
             </a:r>
+            <a:endParaRPr sz="2000" b="1" i="0">
+              <a:solidFill>
+                <a:srgbClr val="5EBEFF"/>
+              </a:solidFill>
+              <a:latin typeface="Aptos"/>
+            </a:endParaRPr>
           </a:p>
         </p:txBody>
       </p:sp>
@@ -12524,6 +13548,12 @@
               </a:rPr>
               <a:t>Revisar o resultado</a:t>
             </a:r>
+            <a:endParaRPr sz="1600" b="1" i="0">
+              <a:solidFill>
+                <a:srgbClr val="F6F9FC"/>
+              </a:solidFill>
+              <a:latin typeface="Aptos"/>
+            </a:endParaRPr>
           </a:p>
         </p:txBody>
       </p:sp>
@@ -12563,6 +13593,12 @@
               </a:rPr>
               <a:t>Usuário verifica os dados exibidos e segue a rotina.</a:t>
             </a:r>
+            <a:endParaRPr sz="1100" b="0" i="0">
+              <a:solidFill>
+                <a:srgbClr val="AEBED2"/>
+              </a:solidFill>
+              <a:latin typeface="Aptos"/>
+            </a:endParaRPr>
           </a:p>
         </p:txBody>
       </p:sp>
@@ -12602,6 +13638,12 @@
               </a:rPr>
               <a:t>O comportamento final depende dos recursos implementados em cada tela e dos requisitos definidos pelo grupo.</a:t>
             </a:r>
+            <a:endParaRPr sz="1200" b="0" i="1">
+              <a:solidFill>
+                <a:srgbClr val="FFC25C"/>
+              </a:solidFill>
+              <a:latin typeface="Aptos"/>
+            </a:endParaRPr>
           </a:p>
         </p:txBody>
       </p:sp>
@@ -12641,6 +13683,12 @@
               </a:rPr>
               <a:t>NEXUS GESTÃO  •  PROJETO ACADÊMICO</a:t>
             </a:r>
+            <a:endParaRPr sz="900" b="0" i="0">
+              <a:solidFill>
+                <a:srgbClr val="AEBED2"/>
+              </a:solidFill>
+              <a:latin typeface="Aptos"/>
+            </a:endParaRPr>
           </a:p>
         </p:txBody>
       </p:sp>
@@ -12653,7 +13701,7 @@
 </file>
 
 <file path=ppt/slides/slide9.xml><?xml version="1.0" encoding="utf-8"?>
-<p:sld xmlns:a="http://schemas.openxmlformats.org/drawingml/2006/main" xmlns:p="http://schemas.openxmlformats.org/presentationml/2006/main" xmlns:r="http://schemas.openxmlformats.org/officeDocument/2006/relationships">
+<p:sld xmlns:a="http://schemas.openxmlformats.org/drawingml/2006/main" xmlns:r="http://schemas.openxmlformats.org/officeDocument/2006/relationships" xmlns:p="http://schemas.openxmlformats.org/presentationml/2006/main">
   <p:cSld>
     <p:bg>
       <p:bgPr>
@@ -12706,6 +13754,12 @@
               </a:rPr>
               <a:t>08 • DECISÕES DE PROJETO</a:t>
             </a:r>
+            <a:endParaRPr sz="1000" b="1" i="0">
+              <a:solidFill>
+                <a:srgbClr val="28D6BE"/>
+              </a:solidFill>
+              <a:latin typeface="Aptos"/>
+            </a:endParaRPr>
           </a:p>
         </p:txBody>
       </p:sp>
@@ -12745,6 +13799,12 @@
               </a:rPr>
               <a:t>O que a estrutura favorece</a:t>
             </a:r>
+            <a:endParaRPr sz="2900" b="1" i="0">
+              <a:solidFill>
+                <a:srgbClr val="F6F9FC"/>
+              </a:solidFill>
+              <a:latin typeface="Aptos"/>
+            </a:endParaRPr>
           </a:p>
         </p:txBody>
       </p:sp>
@@ -12784,6 +13844,12 @@
               </a:rPr>
               <a:t>A separação visual e técnica cria uma base para evoluir o protótipo.</a:t>
             </a:r>
+            <a:endParaRPr sz="1300" b="0" i="0">
+              <a:solidFill>
+                <a:srgbClr val="AEBED2"/>
+              </a:solidFill>
+              <a:latin typeface="Aptos"/>
+            </a:endParaRPr>
           </a:p>
         </p:txBody>
       </p:sp>
@@ -12866,6 +13932,12 @@
               </a:rPr>
               <a:t>09</a:t>
             </a:r>
+            <a:endParaRPr sz="1000" b="1" i="0">
+              <a:solidFill>
+                <a:srgbClr val="AEBED2"/>
+              </a:solidFill>
+              <a:latin typeface="Aptos"/>
+            </a:endParaRPr>
           </a:p>
         </p:txBody>
       </p:sp>
@@ -12991,6 +14063,12 @@
               </a:rPr>
               <a:t>Organização</a:t>
             </a:r>
+            <a:endParaRPr sz="1600" b="1" i="0">
+              <a:solidFill>
+                <a:srgbClr val="F6F9FC"/>
+              </a:solidFill>
+              <a:latin typeface="Aptos"/>
+            </a:endParaRPr>
           </a:p>
         </p:txBody>
       </p:sp>
@@ -13030,6 +14108,12 @@
               </a:rPr>
               <a:t>Módulos separados por tipo de informação facilitam a navegação.</a:t>
             </a:r>
+            <a:endParaRPr sz="1200" b="0" i="0">
+              <a:solidFill>
+                <a:srgbClr val="AEBED2"/>
+              </a:solidFill>
+              <a:latin typeface="Aptos"/>
+            </a:endParaRPr>
           </a:p>
         </p:txBody>
       </p:sp>
@@ -13155,6 +14239,12 @@
               </a:rPr>
               <a:t>Manutenção</a:t>
             </a:r>
+            <a:endParaRPr sz="1600" b="1" i="0">
+              <a:solidFill>
+                <a:srgbClr val="F6F9FC"/>
+              </a:solidFill>
+              <a:latin typeface="Aptos"/>
+            </a:endParaRPr>
           </a:p>
         </p:txBody>
       </p:sp>
@@ -13194,6 +14284,12 @@
               </a:rPr>
               <a:t>Projetos organizados por responsabilidade podem evoluir em etapas.</a:t>
             </a:r>
+            <a:endParaRPr sz="1200" b="0" i="0">
+              <a:solidFill>
+                <a:srgbClr val="AEBED2"/>
+              </a:solidFill>
+              <a:latin typeface="Aptos"/>
+            </a:endParaRPr>
           </a:p>
         </p:txBody>
       </p:sp>
@@ -13319,6 +14415,12 @@
               </a:rPr>
               <a:t>Evolução</a:t>
             </a:r>
+            <a:endParaRPr sz="1600" b="1" i="0">
+              <a:solidFill>
+                <a:srgbClr val="F6F9FC"/>
+              </a:solidFill>
+              <a:latin typeface="Aptos"/>
+            </a:endParaRPr>
           </a:p>
         </p:txBody>
       </p:sp>
@@ -13358,6 +14460,12 @@
               </a:rPr>
               <a:t>A API abre caminho para integração com outras interfaces ou clientes.</a:t>
             </a:r>
+            <a:endParaRPr sz="1200" b="0" i="0">
+              <a:solidFill>
+                <a:srgbClr val="AEBED2"/>
+              </a:solidFill>
+              <a:latin typeface="Aptos"/>
+            </a:endParaRPr>
           </a:p>
         </p:txBody>
       </p:sp>
@@ -13397,6 +14505,12 @@
               </a:rPr>
               <a:t>Princípio importante</a:t>
             </a:r>
+            <a:endParaRPr sz="1500" b="1" i="0">
+              <a:solidFill>
+                <a:srgbClr val="28D6BE"/>
+              </a:solidFill>
+              <a:latin typeface="Aptos"/>
+            </a:endParaRPr>
           </a:p>
         </p:txBody>
       </p:sp>
@@ -13436,6 +14550,12 @@
               </a:rPr>
               <a:t>Um protótipo bem apresentado deixa claro o que já funciona, o que está separado e o que ainda será desenvolvido.</a:t>
             </a:r>
+            <a:endParaRPr sz="2100" b="1" i="0">
+              <a:solidFill>
+                <a:srgbClr val="F6F9FC"/>
+              </a:solidFill>
+              <a:latin typeface="Aptos"/>
+            </a:endParaRPr>
           </a:p>
         </p:txBody>
       </p:sp>
@@ -13475,6 +14595,12 @@
               </a:rPr>
               <a:t>NEXUS GESTÃO  •  PROJETO ACADÊMICO</a:t>
             </a:r>
+            <a:endParaRPr sz="900" b="0" i="0">
+              <a:solidFill>
+                <a:srgbClr val="AEBED2"/>
+              </a:solidFill>
+              <a:latin typeface="Aptos"/>
+            </a:endParaRPr>
           </a:p>
         </p:txBody>
       </p:sp>
@@ -13802,6 +14928,10 @@
       </a:style>
     </a:lnDef>
   </a:objectDefaults>
-  <a:extraClrSchemeLst/>
+  <a:extLst>
+    <a:ext uri="{05A4C25C-085E-4340-85A3-A5531E510DB2}">
+      <thm15:themeFamily xmlns:thm15="http://schemas.microsoft.com/office/thememl/2012/main" name="Office Theme" id="{62F939B6-93AF-4DB8-9C6B-D6C7DFDC589F}" vid="{4A3C46E8-61CC-4603-A589-7422A47A8E4A}"/>
+    </a:ext>
+  </a:extLst>
 </a:theme>
 </file>
</xml_diff>